<commit_message>
Remove LiteLLM/proxy references from slides and HTML
- 슬롯3: PART4 LiteLLM Proxy 슬라이드 3장 제거, YAML deepseek 업데이트
- 슬롯4: PART1 nb01 proxy 연결 슬라이드 5장 제거, 타이틀/목표 업데이트
- 슬롯5: LITELLM_* → DEEPSEEK_* 코드 업데이트
- setup.html: LiteLLM 도구 카드 제거, 당일 준비 → API key 등록으로 교체
- index.html: 강의3 설명 수정

Co-Authored-By: Claude Sonnet 4.6 <noreply@anthropic.com>
</commit_message>
<xml_diff>
--- a/ws02/class/ws02_슬롯3_방어대책_promptfoo.pptx
+++ b/ws02/class/ws02_슬롯3_방어대책_promptfoo.pptx
@@ -24,9 +24,6 @@
     <p:sldId id="269" r:id="rId15"/>
     <p:sldId id="270" r:id="rId16"/>
     <p:sldId id="271" r:id="rId17"/>
-    <p:sldId id="272" r:id="rId18"/>
-    <p:sldId id="273" r:id="rId19"/>
-    <p:sldId id="274" r:id="rId20"/>
     <p:sldId id="275" r:id="rId21"/>
     <p:sldId id="276" r:id="rId22"/>
   </p:sldIdLst>
@@ -911,258 +908,6 @@
             <a:fld id="{F7021451-1387-4CA6-816F-3879F97B5CBC}" type="slidenum">
               <a:rPr lang="en-US"/>
               <a:t>16</a:t>
-            </a:fld>
-            <a:endParaRPr lang="en-US"/>
-          </a:p>
-        </p:txBody>
-      </p:sp>
-    </p:spTree>
-    <p:extLst>
-      <p:ext uri="{BB962C8B-B14F-4D97-AF65-F5344CB8AC3E}">
-        <p14:creationId xmlns:p14="http://schemas.microsoft.com/office/powerpoint/2010/main" val="1024086991"/>
-      </p:ext>
-    </p:extLst>
-  </p:cSld>
-  <p:clrMapOvr>
-    <a:masterClrMapping/>
-  </p:clrMapOvr>
-</p:notes>
-</file>
-
-<file path=ppt/notesSlides/notesSlide17.xml><?xml version="1.0" encoding="utf-8"?>
-<p:notes xmlns:a="http://schemas.openxmlformats.org/drawingml/2006/main" xmlns:r="http://schemas.openxmlformats.org/officeDocument/2006/relationships" xmlns:p="http://schemas.openxmlformats.org/presentationml/2006/main">
-  <p:cSld>
-    <p:spTree>
-      <p:nvGrpSpPr>
-        <p:cNvPr id="1" name=""/>
-        <p:cNvGrpSpPr/>
-        <p:nvPr/>
-      </p:nvGrpSpPr>
-      <p:grpSpPr>
-        <a:xfrm>
-          <a:off x="0" y="0"/>
-          <a:ext cx="0" cy="0"/>
-          <a:chOff x="0" y="0"/>
-          <a:chExt cx="0" cy="0"/>
-        </a:xfrm>
-      </p:grpSpPr>
-      <p:sp>
-        <p:nvSpPr>
-          <p:cNvPr id="2" name="Slide Image Placeholder 1"/>
-          <p:cNvSpPr>
-            <a:spLocks noGrp="1" noRot="1" noChangeAspect="1"/>
-          </p:cNvSpPr>
-          <p:nvPr>
-            <p:ph type="sldImg"/>
-          </p:nvPr>
-        </p:nvSpPr>
-        <p:spPr/>
-      </p:sp>
-      <p:sp>
-        <p:nvSpPr>
-          <p:cNvPr id="3" name="Notes Placeholder 2"/>
-          <p:cNvSpPr>
-            <a:spLocks noGrp="1"/>
-          </p:cNvSpPr>
-          <p:nvPr>
-            <p:ph type="body" idx="1"/>
-          </p:nvPr>
-        </p:nvSpPr>
-        <p:spPr/>
-        <p:txBody>
-          <a:bodyPr/>
-          <a:lstStyle/>
-          <a:p>
-            <a:endParaRPr lang="en-US" dirty="0"/>
-          </a:p>
-        </p:txBody>
-      </p:sp>
-      <p:sp>
-        <p:nvSpPr>
-          <p:cNvPr id="4" name="Slide Number Placeholder 3"/>
-          <p:cNvSpPr>
-            <a:spLocks noGrp="1"/>
-          </p:cNvSpPr>
-          <p:nvPr>
-            <p:ph type="sldNum" sz="quarter" idx="10"/>
-          </p:nvPr>
-        </p:nvSpPr>
-        <p:spPr/>
-        <p:txBody>
-          <a:bodyPr/>
-          <a:lstStyle/>
-          <a:p>
-            <a:fld id="{F7021451-1387-4CA6-816F-3879F97B5CBC}" type="slidenum">
-              <a:rPr lang="en-US"/>
-              <a:t>17</a:t>
-            </a:fld>
-            <a:endParaRPr lang="en-US"/>
-          </a:p>
-        </p:txBody>
-      </p:sp>
-    </p:spTree>
-    <p:extLst>
-      <p:ext uri="{BB962C8B-B14F-4D97-AF65-F5344CB8AC3E}">
-        <p14:creationId xmlns:p14="http://schemas.microsoft.com/office/powerpoint/2010/main" val="1024086991"/>
-      </p:ext>
-    </p:extLst>
-  </p:cSld>
-  <p:clrMapOvr>
-    <a:masterClrMapping/>
-  </p:clrMapOvr>
-</p:notes>
-</file>
-
-<file path=ppt/notesSlides/notesSlide18.xml><?xml version="1.0" encoding="utf-8"?>
-<p:notes xmlns:a="http://schemas.openxmlformats.org/drawingml/2006/main" xmlns:r="http://schemas.openxmlformats.org/officeDocument/2006/relationships" xmlns:p="http://schemas.openxmlformats.org/presentationml/2006/main">
-  <p:cSld>
-    <p:spTree>
-      <p:nvGrpSpPr>
-        <p:cNvPr id="1" name=""/>
-        <p:cNvGrpSpPr/>
-        <p:nvPr/>
-      </p:nvGrpSpPr>
-      <p:grpSpPr>
-        <a:xfrm>
-          <a:off x="0" y="0"/>
-          <a:ext cx="0" cy="0"/>
-          <a:chOff x="0" y="0"/>
-          <a:chExt cx="0" cy="0"/>
-        </a:xfrm>
-      </p:grpSpPr>
-      <p:sp>
-        <p:nvSpPr>
-          <p:cNvPr id="2" name="Slide Image Placeholder 1"/>
-          <p:cNvSpPr>
-            <a:spLocks noGrp="1" noRot="1" noChangeAspect="1"/>
-          </p:cNvSpPr>
-          <p:nvPr>
-            <p:ph type="sldImg"/>
-          </p:nvPr>
-        </p:nvSpPr>
-        <p:spPr/>
-      </p:sp>
-      <p:sp>
-        <p:nvSpPr>
-          <p:cNvPr id="3" name="Notes Placeholder 2"/>
-          <p:cNvSpPr>
-            <a:spLocks noGrp="1"/>
-          </p:cNvSpPr>
-          <p:nvPr>
-            <p:ph type="body" idx="1"/>
-          </p:nvPr>
-        </p:nvSpPr>
-        <p:spPr/>
-        <p:txBody>
-          <a:bodyPr/>
-          <a:lstStyle/>
-          <a:p>
-            <a:endParaRPr lang="en-US" dirty="0"/>
-          </a:p>
-        </p:txBody>
-      </p:sp>
-      <p:sp>
-        <p:nvSpPr>
-          <p:cNvPr id="4" name="Slide Number Placeholder 3"/>
-          <p:cNvSpPr>
-            <a:spLocks noGrp="1"/>
-          </p:cNvSpPr>
-          <p:nvPr>
-            <p:ph type="sldNum" sz="quarter" idx="10"/>
-          </p:nvPr>
-        </p:nvSpPr>
-        <p:spPr/>
-        <p:txBody>
-          <a:bodyPr/>
-          <a:lstStyle/>
-          <a:p>
-            <a:fld id="{F7021451-1387-4CA6-816F-3879F97B5CBC}" type="slidenum">
-              <a:rPr lang="en-US"/>
-              <a:t>18</a:t>
-            </a:fld>
-            <a:endParaRPr lang="en-US"/>
-          </a:p>
-        </p:txBody>
-      </p:sp>
-    </p:spTree>
-    <p:extLst>
-      <p:ext uri="{BB962C8B-B14F-4D97-AF65-F5344CB8AC3E}">
-        <p14:creationId xmlns:p14="http://schemas.microsoft.com/office/powerpoint/2010/main" val="1024086991"/>
-      </p:ext>
-    </p:extLst>
-  </p:cSld>
-  <p:clrMapOvr>
-    <a:masterClrMapping/>
-  </p:clrMapOvr>
-</p:notes>
-</file>
-
-<file path=ppt/notesSlides/notesSlide19.xml><?xml version="1.0" encoding="utf-8"?>
-<p:notes xmlns:a="http://schemas.openxmlformats.org/drawingml/2006/main" xmlns:r="http://schemas.openxmlformats.org/officeDocument/2006/relationships" xmlns:p="http://schemas.openxmlformats.org/presentationml/2006/main">
-  <p:cSld>
-    <p:spTree>
-      <p:nvGrpSpPr>
-        <p:cNvPr id="1" name=""/>
-        <p:cNvGrpSpPr/>
-        <p:nvPr/>
-      </p:nvGrpSpPr>
-      <p:grpSpPr>
-        <a:xfrm>
-          <a:off x="0" y="0"/>
-          <a:ext cx="0" cy="0"/>
-          <a:chOff x="0" y="0"/>
-          <a:chExt cx="0" cy="0"/>
-        </a:xfrm>
-      </p:grpSpPr>
-      <p:sp>
-        <p:nvSpPr>
-          <p:cNvPr id="2" name="Slide Image Placeholder 1"/>
-          <p:cNvSpPr>
-            <a:spLocks noGrp="1" noRot="1" noChangeAspect="1"/>
-          </p:cNvSpPr>
-          <p:nvPr>
-            <p:ph type="sldImg"/>
-          </p:nvPr>
-        </p:nvSpPr>
-        <p:spPr/>
-      </p:sp>
-      <p:sp>
-        <p:nvSpPr>
-          <p:cNvPr id="3" name="Notes Placeholder 2"/>
-          <p:cNvSpPr>
-            <a:spLocks noGrp="1"/>
-          </p:cNvSpPr>
-          <p:nvPr>
-            <p:ph type="body" idx="1"/>
-          </p:nvPr>
-        </p:nvSpPr>
-        <p:spPr/>
-        <p:txBody>
-          <a:bodyPr/>
-          <a:lstStyle/>
-          <a:p>
-            <a:endParaRPr lang="en-US" dirty="0"/>
-          </a:p>
-        </p:txBody>
-      </p:sp>
-      <p:sp>
-        <p:nvSpPr>
-          <p:cNvPr id="4" name="Slide Number Placeholder 3"/>
-          <p:cNvSpPr>
-            <a:spLocks noGrp="1"/>
-          </p:cNvSpPr>
-          <p:nvPr>
-            <p:ph type="sldNum" sz="quarter" idx="10"/>
-          </p:nvPr>
-        </p:nvSpPr>
-        <p:spPr/>
-        <p:txBody>
-          <a:bodyPr/>
-          <a:lstStyle/>
-          <a:p>
-            <a:fld id="{F7021451-1387-4CA6-816F-3879F97B5CBC}" type="slidenum">
-              <a:rPr lang="en-US"/>
-              <a:t>19</a:t>
             </a:fld>
             <a:endParaRPr lang="en-US"/>
           </a:p>
@@ -2824,7 +2569,7 @@
                   <a:srgbClr val="FFFFFF"/>
                 </a:solidFill>
               </a:rPr>
-              <a:t>LiteLLM + 실습 안내</a:t>
+              <a:t>실습 안내</a:t>
             </a:r>
             <a:endParaRPr lang="en-US" sz="1300" dirty="0"/>
           </a:p>
@@ -5210,7 +4955,7 @@
                 <a:ea typeface="Courier New" pitchFamily="34" charset="-122"/>
                 <a:cs typeface="Courier New" pitchFamily="34" charset="-120"/>
               </a:rPr>
-              <a:t>  - id: openai:chat:gemini-2.5-flash-lite
+              <a:t>  - id: openai:chat:deepseek-chat
 </a:t>
             </a:r>
             <a:r>
@@ -5234,7 +4979,7 @@
                 <a:ea typeface="Courier New" pitchFamily="34" charset="-122"/>
                 <a:cs typeface="Courier New" pitchFamily="34" charset="-120"/>
               </a:rPr>
-              <a:t>      apiBaseUrl: http://[강사IP]:4000/v1
+              <a:t>      apiBaseUrl: https://api.deepseek.com/v1
 </a:t>
             </a:r>
             <a:r>
@@ -9336,2571 +9081,6 @@
 </p:sld>
 </file>
 
-<file path=ppt/slides/slide17.xml><?xml version="1.0" encoding="utf-8"?>
-<p:sld xmlns:a="http://schemas.openxmlformats.org/drawingml/2006/main" xmlns:r="http://schemas.openxmlformats.org/officeDocument/2006/relationships" xmlns:p="http://schemas.openxmlformats.org/presentationml/2006/main">
-  <p:cSld name="Slide 17">
-    <p:bg>
-      <p:bgPr>
-        <a:solidFill>
-          <a:srgbClr val="1A1F3A"/>
-        </a:solidFill>
-        <a:effectLst/>
-      </p:bgPr>
-    </p:bg>
-    <p:spTree>
-      <p:nvGrpSpPr>
-        <p:cNvPr id="1" name=""/>
-        <p:cNvGrpSpPr/>
-        <p:nvPr/>
-      </p:nvGrpSpPr>
-      <p:grpSpPr>
-        <a:xfrm>
-          <a:off x="0" y="0"/>
-          <a:ext cx="0" cy="0"/>
-          <a:chOff x="0" y="0"/>
-          <a:chExt cx="0" cy="0"/>
-        </a:xfrm>
-      </p:grpSpPr>
-      <p:sp>
-        <p:nvSpPr>
-          <p:cNvPr id="2" name="Shape 0"/>
-          <p:cNvSpPr/>
-          <p:nvPr/>
-        </p:nvSpPr>
-        <p:spPr>
-          <a:xfrm>
-            <a:off x="457200" y="1371600"/>
-            <a:ext cx="73152" cy="2377440"/>
-          </a:xfrm>
-          <a:prstGeom prst="rect">
-            <a:avLst/>
-          </a:prstGeom>
-          <a:solidFill>
-            <a:srgbClr val="E8A825"/>
-          </a:solidFill>
-          <a:ln w="12700">
-            <a:solidFill>
-              <a:srgbClr val="E8A825"/>
-            </a:solidFill>
-            <a:prstDash val="solid"/>
-          </a:ln>
-        </p:spPr>
-        <p:txBody>
-          <a:bodyPr/>
-          <a:lstStyle/>
-          <a:p>
-            <a:endParaRPr/>
-          </a:p>
-        </p:txBody>
-      </p:sp>
-      <p:sp>
-        <p:nvSpPr>
-          <p:cNvPr id="3" name="Text 1"/>
-          <p:cNvSpPr/>
-          <p:nvPr/>
-        </p:nvSpPr>
-        <p:spPr>
-          <a:xfrm>
-            <a:off x="685800" y="1280160"/>
-            <a:ext cx="7315200" cy="411480"/>
-          </a:xfrm>
-          <a:prstGeom prst="rect">
-            <a:avLst/>
-          </a:prstGeom>
-          <a:noFill/>
-          <a:ln/>
-        </p:spPr>
-        <p:txBody>
-          <a:bodyPr wrap="square" lIns="0" tIns="0" rIns="0" bIns="0" rtlCol="0" anchor="ctr"/>
-          <a:lstStyle/>
-          <a:p>
-            <a:pPr marL="0" indent="0">
-              <a:buNone/>
-            </a:pPr>
-            <a:r>
-              <a:rPr lang="en-US" sz="1300" b="1" kern="0" spc="400" dirty="0">
-                <a:solidFill>
-                  <a:srgbClr val="E8A825"/>
-                </a:solidFill>
-              </a:rPr>
-              <a:t>PART 4</a:t>
-            </a:r>
-            <a:endParaRPr lang="en-US" sz="1300" dirty="0"/>
-          </a:p>
-        </p:txBody>
-      </p:sp>
-      <p:sp>
-        <p:nvSpPr>
-          <p:cNvPr id="4" name="Text 2"/>
-          <p:cNvSpPr/>
-          <p:nvPr/>
-        </p:nvSpPr>
-        <p:spPr>
-          <a:xfrm>
-            <a:off x="685800" y="1691640"/>
-            <a:ext cx="7772400" cy="1280160"/>
-          </a:xfrm>
-          <a:prstGeom prst="rect">
-            <a:avLst/>
-          </a:prstGeom>
-          <a:noFill/>
-          <a:ln/>
-        </p:spPr>
-        <p:txBody>
-          <a:bodyPr wrap="square" lIns="0" tIns="0" rIns="0" bIns="0" rtlCol="0" anchor="ctr"/>
-          <a:lstStyle/>
-          <a:p>
-            <a:pPr marL="0" indent="0">
-              <a:buNone/>
-            </a:pPr>
-            <a:r>
-              <a:rPr lang="en-US" sz="3400" b="1" dirty="0">
-                <a:solidFill>
-                  <a:srgbClr val="FFFFFF"/>
-                </a:solidFill>
-              </a:rPr>
-              <a:t>LiteLLM Proxy</a:t>
-            </a:r>
-            <a:endParaRPr lang="en-US" sz="3400" dirty="0"/>
-          </a:p>
-          <a:p>
-            <a:pPr marL="0" indent="0">
-              <a:buNone/>
-            </a:pPr>
-            <a:r>
-              <a:rPr lang="en-US" sz="3400" b="1" dirty="0">
-                <a:solidFill>
-                  <a:srgbClr val="FFFFFF"/>
-                </a:solidFill>
-              </a:rPr>
-              <a:t>+ 실습 안내</a:t>
-            </a:r>
-            <a:endParaRPr lang="en-US" sz="3400" dirty="0"/>
-          </a:p>
-        </p:txBody>
-      </p:sp>
-      <p:sp>
-        <p:nvSpPr>
-          <p:cNvPr id="5" name="Text 3"/>
-          <p:cNvSpPr/>
-          <p:nvPr/>
-        </p:nvSpPr>
-        <p:spPr>
-          <a:xfrm>
-            <a:off x="685800" y="3017520"/>
-            <a:ext cx="4572000" cy="411480"/>
-          </a:xfrm>
-          <a:prstGeom prst="rect">
-            <a:avLst/>
-          </a:prstGeom>
-          <a:noFill/>
-          <a:ln/>
-        </p:spPr>
-        <p:txBody>
-          <a:bodyPr wrap="square" lIns="0" tIns="0" rIns="0" bIns="0" rtlCol="0" anchor="ctr"/>
-          <a:lstStyle/>
-          <a:p>
-            <a:pPr marL="0" indent="0">
-              <a:buNone/>
-            </a:pPr>
-            <a:r>
-              <a:rPr lang="en-US" sz="1400" dirty="0">
-                <a:solidFill>
-                  <a:srgbClr val="8899AA"/>
-                </a:solidFill>
-              </a:rPr>
-              <a:t>연결 방법 · 트러블슈팅</a:t>
-            </a:r>
-            <a:endParaRPr lang="en-US" sz="1400" dirty="0"/>
-          </a:p>
-        </p:txBody>
-      </p:sp>
-      <p:sp>
-        <p:nvSpPr>
-          <p:cNvPr id="6" name="Text 4"/>
-          <p:cNvSpPr/>
-          <p:nvPr/>
-        </p:nvSpPr>
-        <p:spPr>
-          <a:xfrm>
-            <a:off x="0" y="4754880"/>
-            <a:ext cx="9144000" cy="320040"/>
-          </a:xfrm>
-          <a:prstGeom prst="rect">
-            <a:avLst/>
-          </a:prstGeom>
-          <a:noFill/>
-          <a:ln/>
-        </p:spPr>
-        <p:txBody>
-          <a:bodyPr wrap="square" lIns="0" tIns="0" rIns="0" bIns="0" rtlCol="0" anchor="ctr"/>
-          <a:lstStyle/>
-          <a:p>
-            <a:pPr marL="0" indent="0" algn="r">
-              <a:buNone/>
-            </a:pPr>
-            <a:r>
-              <a:rPr lang="en-US" sz="1100" dirty="0">
-                <a:solidFill>
-                  <a:srgbClr val="8899AA"/>
-                </a:solidFill>
-              </a:rPr>
-              <a:t>보안이 없으면, AI도 없습니다.</a:t>
-            </a:r>
-            <a:endParaRPr lang="en-US" sz="1100" dirty="0"/>
-          </a:p>
-        </p:txBody>
-      </p:sp>
-    </p:spTree>
-  </p:cSld>
-  <p:clrMapOvr>
-    <a:masterClrMapping/>
-  </p:clrMapOvr>
-</p:sld>
-</file>
-
-<file path=ppt/slides/slide18.xml><?xml version="1.0" encoding="utf-8"?>
-<p:sld xmlns:a="http://schemas.openxmlformats.org/drawingml/2006/main" xmlns:r="http://schemas.openxmlformats.org/officeDocument/2006/relationships" xmlns:p="http://schemas.openxmlformats.org/presentationml/2006/main">
-  <p:cSld name="Slide 18">
-    <p:bg>
-      <p:bgPr>
-        <a:solidFill>
-          <a:srgbClr val="F4F6FB"/>
-        </a:solidFill>
-        <a:effectLst/>
-      </p:bgPr>
-    </p:bg>
-    <p:spTree>
-      <p:nvGrpSpPr>
-        <p:cNvPr id="1" name=""/>
-        <p:cNvGrpSpPr/>
-        <p:nvPr/>
-      </p:nvGrpSpPr>
-      <p:grpSpPr>
-        <a:xfrm>
-          <a:off x="0" y="0"/>
-          <a:ext cx="0" cy="0"/>
-          <a:chOff x="0" y="0"/>
-          <a:chExt cx="0" cy="0"/>
-        </a:xfrm>
-      </p:grpSpPr>
-      <p:sp>
-        <p:nvSpPr>
-          <p:cNvPr id="2" name="Shape 0"/>
-          <p:cNvSpPr/>
-          <p:nvPr/>
-        </p:nvSpPr>
-        <p:spPr>
-          <a:xfrm>
-            <a:off x="0" y="0"/>
-            <a:ext cx="9144000" cy="658368"/>
-          </a:xfrm>
-          <a:prstGeom prst="rect">
-            <a:avLst/>
-          </a:prstGeom>
-          <a:solidFill>
-            <a:srgbClr val="1A1F3A"/>
-          </a:solidFill>
-          <a:ln w="12700">
-            <a:solidFill>
-              <a:srgbClr val="1A1F3A"/>
-            </a:solidFill>
-            <a:prstDash val="solid"/>
-          </a:ln>
-        </p:spPr>
-        <p:txBody>
-          <a:bodyPr/>
-          <a:lstStyle/>
-          <a:p>
-            <a:endParaRPr/>
-          </a:p>
-        </p:txBody>
-      </p:sp>
-      <p:sp>
-        <p:nvSpPr>
-          <p:cNvPr id="3" name="Text 1"/>
-          <p:cNvSpPr/>
-          <p:nvPr/>
-        </p:nvSpPr>
-        <p:spPr>
-          <a:xfrm>
-            <a:off x="411480" y="91440"/>
-            <a:ext cx="8321040" cy="457200"/>
-          </a:xfrm>
-          <a:prstGeom prst="rect">
-            <a:avLst/>
-          </a:prstGeom>
-          <a:noFill/>
-          <a:ln/>
-        </p:spPr>
-        <p:txBody>
-          <a:bodyPr wrap="square" lIns="0" tIns="0" rIns="0" bIns="0" rtlCol="0" anchor="ctr"/>
-          <a:lstStyle/>
-          <a:p>
-            <a:pPr marL="0" indent="0">
-              <a:buNone/>
-            </a:pPr>
-            <a:r>
-              <a:rPr lang="en-US" sz="2000" b="1" dirty="0">
-                <a:solidFill>
-                  <a:srgbClr val="FFFFFF"/>
-                </a:solidFill>
-              </a:rPr>
-              <a:t>LiteLLM Proxy — 연결 구조</a:t>
-            </a:r>
-            <a:endParaRPr lang="en-US" sz="2000" dirty="0"/>
-          </a:p>
-        </p:txBody>
-      </p:sp>
-      <p:sp>
-        <p:nvSpPr>
-          <p:cNvPr id="4" name="Text 2"/>
-          <p:cNvSpPr/>
-          <p:nvPr/>
-        </p:nvSpPr>
-        <p:spPr>
-          <a:xfrm>
-            <a:off x="411480" y="658368"/>
-            <a:ext cx="8321040" cy="292608"/>
-          </a:xfrm>
-          <a:prstGeom prst="rect">
-            <a:avLst/>
-          </a:prstGeom>
-          <a:noFill/>
-          <a:ln/>
-        </p:spPr>
-        <p:txBody>
-          <a:bodyPr wrap="square" lIns="0" tIns="0" rIns="0" bIns="0" rtlCol="0" anchor="ctr"/>
-          <a:lstStyle/>
-          <a:p>
-            <a:pPr marL="0" indent="0">
-              <a:buNone/>
-            </a:pPr>
-            <a:r>
-              <a:rPr lang="en-US" sz="1200" dirty="0">
-                <a:solidFill>
-                  <a:srgbClr val="8899AA"/>
-                </a:solidFill>
-              </a:rPr>
-              <a:t>강사 노트북이 허브, 수강생은 와이파이로 접속</a:t>
-            </a:r>
-            <a:endParaRPr lang="en-US" sz="1200" dirty="0"/>
-          </a:p>
-        </p:txBody>
-      </p:sp>
-      <p:sp>
-        <p:nvSpPr>
-          <p:cNvPr id="5" name="Shape 3"/>
-          <p:cNvSpPr/>
-          <p:nvPr/>
-        </p:nvSpPr>
-        <p:spPr>
-          <a:xfrm>
-            <a:off x="320040" y="1005840"/>
-            <a:ext cx="2651760" cy="1005840"/>
-          </a:xfrm>
-          <a:prstGeom prst="rect">
-            <a:avLst/>
-          </a:prstGeom>
-          <a:solidFill>
-            <a:srgbClr val="5B6FBC"/>
-          </a:solidFill>
-          <a:ln w="12700">
-            <a:solidFill>
-              <a:srgbClr val="5B6FBC"/>
-            </a:solidFill>
-            <a:prstDash val="solid"/>
-          </a:ln>
-          <a:effectLst>
-            <a:outerShdw blurRad="101600" dist="38100" dir="8100000" algn="bl" rotWithShape="0">
-              <a:srgbClr val="000000">
-                <a:alpha val="18000"/>
-              </a:srgbClr>
-            </a:outerShdw>
-          </a:effectLst>
-        </p:spPr>
-        <p:txBody>
-          <a:bodyPr/>
-          <a:lstStyle/>
-          <a:p>
-            <a:endParaRPr/>
-          </a:p>
-        </p:txBody>
-      </p:sp>
-      <p:sp>
-        <p:nvSpPr>
-          <p:cNvPr id="6" name="Text 4"/>
-          <p:cNvSpPr/>
-          <p:nvPr/>
-        </p:nvSpPr>
-        <p:spPr>
-          <a:xfrm>
-            <a:off x="320040" y="1078992"/>
-            <a:ext cx="2651760" cy="530352"/>
-          </a:xfrm>
-          <a:prstGeom prst="rect">
-            <a:avLst/>
-          </a:prstGeom>
-          <a:noFill/>
-          <a:ln/>
-        </p:spPr>
-        <p:txBody>
-          <a:bodyPr wrap="square" lIns="0" tIns="0" rIns="0" bIns="0" rtlCol="0" anchor="ctr"/>
-          <a:lstStyle/>
-          <a:p>
-            <a:pPr marL="0" indent="0" algn="ctr">
-              <a:buNone/>
-            </a:pPr>
-            <a:r>
-              <a:rPr lang="en-US" sz="1300" b="1" dirty="0">
-                <a:solidFill>
-                  <a:srgbClr val="FFFFFF"/>
-                </a:solidFill>
-              </a:rPr>
-              <a:t>수강생 노트북 × 15</a:t>
-            </a:r>
-            <a:endParaRPr lang="en-US" sz="1300" dirty="0"/>
-          </a:p>
-        </p:txBody>
-      </p:sp>
-      <p:sp>
-        <p:nvSpPr>
-          <p:cNvPr id="7" name="Text 5"/>
-          <p:cNvSpPr/>
-          <p:nvPr/>
-        </p:nvSpPr>
-        <p:spPr>
-          <a:xfrm>
-            <a:off x="320040" y="1627632"/>
-            <a:ext cx="2651760" cy="320040"/>
-          </a:xfrm>
-          <a:prstGeom prst="rect">
-            <a:avLst/>
-          </a:prstGeom>
-          <a:noFill/>
-          <a:ln/>
-        </p:spPr>
-        <p:txBody>
-          <a:bodyPr wrap="square" lIns="0" tIns="0" rIns="0" bIns="0" rtlCol="0" anchor="ctr"/>
-          <a:lstStyle/>
-          <a:p>
-            <a:pPr marL="0" indent="0" algn="ctr">
-              <a:buNone/>
-            </a:pPr>
-            <a:r>
-              <a:rPr lang="en-US" sz="1050" dirty="0">
-                <a:solidFill>
-                  <a:srgbClr val="CCDDFF"/>
-                </a:solidFill>
-              </a:rPr>
-              <a:t>(Python, Colab)</a:t>
-            </a:r>
-            <a:endParaRPr lang="en-US" sz="1050" dirty="0"/>
-          </a:p>
-        </p:txBody>
-      </p:sp>
-      <p:sp>
-        <p:nvSpPr>
-          <p:cNvPr id="8" name="Shape 6"/>
-          <p:cNvSpPr/>
-          <p:nvPr/>
-        </p:nvSpPr>
-        <p:spPr>
-          <a:xfrm>
-            <a:off x="3246120" y="1005840"/>
-            <a:ext cx="2651760" cy="1005840"/>
-          </a:xfrm>
-          <a:prstGeom prst="rect">
-            <a:avLst/>
-          </a:prstGeom>
-          <a:solidFill>
-            <a:srgbClr val="4A90D9"/>
-          </a:solidFill>
-          <a:ln w="12700">
-            <a:solidFill>
-              <a:srgbClr val="4A90D9"/>
-            </a:solidFill>
-            <a:prstDash val="solid"/>
-          </a:ln>
-          <a:effectLst>
-            <a:outerShdw blurRad="101600" dist="38100" dir="8100000" algn="bl" rotWithShape="0">
-              <a:srgbClr val="000000">
-                <a:alpha val="18000"/>
-              </a:srgbClr>
-            </a:outerShdw>
-          </a:effectLst>
-        </p:spPr>
-        <p:txBody>
-          <a:bodyPr/>
-          <a:lstStyle/>
-          <a:p>
-            <a:endParaRPr/>
-          </a:p>
-        </p:txBody>
-      </p:sp>
-      <p:sp>
-        <p:nvSpPr>
-          <p:cNvPr id="9" name="Text 7"/>
-          <p:cNvSpPr/>
-          <p:nvPr/>
-        </p:nvSpPr>
-        <p:spPr>
-          <a:xfrm>
-            <a:off x="3246120" y="1078992"/>
-            <a:ext cx="2651760" cy="530352"/>
-          </a:xfrm>
-          <a:prstGeom prst="rect">
-            <a:avLst/>
-          </a:prstGeom>
-          <a:noFill/>
-          <a:ln/>
-        </p:spPr>
-        <p:txBody>
-          <a:bodyPr wrap="square" lIns="0" tIns="0" rIns="0" bIns="0" rtlCol="0" anchor="ctr"/>
-          <a:lstStyle/>
-          <a:p>
-            <a:pPr marL="0" indent="0" algn="ctr">
-              <a:buNone/>
-            </a:pPr>
-            <a:r>
-              <a:rPr lang="en-US" sz="1300" b="1" dirty="0">
-                <a:solidFill>
-                  <a:srgbClr val="FFFFFF"/>
-                </a:solidFill>
-              </a:rPr>
-              <a:t>강사 노트북</a:t>
-            </a:r>
-            <a:endParaRPr lang="en-US" sz="1300" dirty="0"/>
-          </a:p>
-          <a:p>
-            <a:pPr marL="0" indent="0" algn="ctr">
-              <a:buNone/>
-            </a:pPr>
-            <a:r>
-              <a:rPr lang="en-US" sz="1300" b="1" dirty="0">
-                <a:solidFill>
-                  <a:srgbClr val="FFFFFF"/>
-                </a:solidFill>
-              </a:rPr>
-              <a:t>:4000</a:t>
-            </a:r>
-            <a:endParaRPr lang="en-US" sz="1300" dirty="0"/>
-          </a:p>
-        </p:txBody>
-      </p:sp>
-      <p:sp>
-        <p:nvSpPr>
-          <p:cNvPr id="10" name="Text 8"/>
-          <p:cNvSpPr/>
-          <p:nvPr/>
-        </p:nvSpPr>
-        <p:spPr>
-          <a:xfrm>
-            <a:off x="3246120" y="1627632"/>
-            <a:ext cx="2651760" cy="320040"/>
-          </a:xfrm>
-          <a:prstGeom prst="rect">
-            <a:avLst/>
-          </a:prstGeom>
-          <a:noFill/>
-          <a:ln/>
-        </p:spPr>
-        <p:txBody>
-          <a:bodyPr wrap="square" lIns="0" tIns="0" rIns="0" bIns="0" rtlCol="0" anchor="ctr"/>
-          <a:lstStyle/>
-          <a:p>
-            <a:pPr marL="0" indent="0" algn="ctr">
-              <a:buNone/>
-            </a:pPr>
-            <a:r>
-              <a:rPr lang="en-US" sz="1050" dirty="0">
-                <a:solidFill>
-                  <a:srgbClr val="CCDDFF"/>
-                </a:solidFill>
-              </a:rPr>
-              <a:t>LiteLLM proxy</a:t>
-            </a:r>
-            <a:endParaRPr lang="en-US" sz="1050" dirty="0"/>
-          </a:p>
-        </p:txBody>
-      </p:sp>
-      <p:sp>
-        <p:nvSpPr>
-          <p:cNvPr id="11" name="Shape 9"/>
-          <p:cNvSpPr/>
-          <p:nvPr/>
-        </p:nvSpPr>
-        <p:spPr>
-          <a:xfrm>
-            <a:off x="6172200" y="1005840"/>
-            <a:ext cx="2651760" cy="1005840"/>
-          </a:xfrm>
-          <a:prstGeom prst="rect">
-            <a:avLst/>
-          </a:prstGeom>
-          <a:solidFill>
-            <a:srgbClr val="3CB371"/>
-          </a:solidFill>
-          <a:ln w="12700">
-            <a:solidFill>
-              <a:srgbClr val="3CB371"/>
-            </a:solidFill>
-            <a:prstDash val="solid"/>
-          </a:ln>
-          <a:effectLst>
-            <a:outerShdw blurRad="101600" dist="38100" dir="8100000" algn="bl" rotWithShape="0">
-              <a:srgbClr val="000000">
-                <a:alpha val="18000"/>
-              </a:srgbClr>
-            </a:outerShdw>
-          </a:effectLst>
-        </p:spPr>
-        <p:txBody>
-          <a:bodyPr/>
-          <a:lstStyle/>
-          <a:p>
-            <a:endParaRPr/>
-          </a:p>
-        </p:txBody>
-      </p:sp>
-      <p:sp>
-        <p:nvSpPr>
-          <p:cNvPr id="12" name="Text 10"/>
-          <p:cNvSpPr/>
-          <p:nvPr/>
-        </p:nvSpPr>
-        <p:spPr>
-          <a:xfrm>
-            <a:off x="6172200" y="1078992"/>
-            <a:ext cx="2651760" cy="530352"/>
-          </a:xfrm>
-          <a:prstGeom prst="rect">
-            <a:avLst/>
-          </a:prstGeom>
-          <a:noFill/>
-          <a:ln/>
-        </p:spPr>
-        <p:txBody>
-          <a:bodyPr wrap="square" lIns="0" tIns="0" rIns="0" bIns="0" rtlCol="0" anchor="ctr"/>
-          <a:lstStyle/>
-          <a:p>
-            <a:pPr marL="0" indent="0" algn="ctr">
-              <a:buNone/>
-            </a:pPr>
-            <a:r>
-              <a:rPr lang="en-US" sz="1300" b="1" dirty="0">
-                <a:solidFill>
-                  <a:srgbClr val="FFFFFF"/>
-                </a:solidFill>
-              </a:rPr>
-              <a:t>Gemini API</a:t>
-            </a:r>
-            <a:endParaRPr lang="en-US" sz="1300" dirty="0"/>
-          </a:p>
-        </p:txBody>
-      </p:sp>
-      <p:sp>
-        <p:nvSpPr>
-          <p:cNvPr id="13" name="Text 11"/>
-          <p:cNvSpPr/>
-          <p:nvPr/>
-        </p:nvSpPr>
-        <p:spPr>
-          <a:xfrm>
-            <a:off x="6172200" y="1627632"/>
-            <a:ext cx="2651760" cy="320040"/>
-          </a:xfrm>
-          <a:prstGeom prst="rect">
-            <a:avLst/>
-          </a:prstGeom>
-          <a:noFill/>
-          <a:ln/>
-        </p:spPr>
-        <p:txBody>
-          <a:bodyPr wrap="square" lIns="0" tIns="0" rIns="0" bIns="0" rtlCol="0" anchor="ctr"/>
-          <a:lstStyle/>
-          <a:p>
-            <a:pPr marL="0" indent="0" algn="ctr">
-              <a:buNone/>
-            </a:pPr>
-            <a:r>
-              <a:rPr lang="en-US" sz="1050" dirty="0">
-                <a:solidFill>
-                  <a:srgbClr val="CCDDFF"/>
-                </a:solidFill>
-              </a:rPr>
-              <a:t>강사 API 키 사용</a:t>
-            </a:r>
-            <a:endParaRPr lang="en-US" sz="1050" dirty="0"/>
-          </a:p>
-        </p:txBody>
-      </p:sp>
-      <p:sp>
-        <p:nvSpPr>
-          <p:cNvPr id="14" name="Shape 12"/>
-          <p:cNvSpPr/>
-          <p:nvPr/>
-        </p:nvSpPr>
-        <p:spPr>
-          <a:xfrm>
-            <a:off x="2990088" y="1353312"/>
-            <a:ext cx="237744" cy="164592"/>
-          </a:xfrm>
-          <a:prstGeom prst="rect">
-            <a:avLst/>
-          </a:prstGeom>
-          <a:solidFill>
-            <a:srgbClr val="8899AA"/>
-          </a:solidFill>
-          <a:ln w="12700">
-            <a:solidFill>
-              <a:srgbClr val="8899AA"/>
-            </a:solidFill>
-            <a:prstDash val="solid"/>
-          </a:ln>
-        </p:spPr>
-        <p:txBody>
-          <a:bodyPr/>
-          <a:lstStyle/>
-          <a:p>
-            <a:endParaRPr/>
-          </a:p>
-        </p:txBody>
-      </p:sp>
-      <p:sp>
-        <p:nvSpPr>
-          <p:cNvPr id="15" name="Shape 13"/>
-          <p:cNvSpPr/>
-          <p:nvPr/>
-        </p:nvSpPr>
-        <p:spPr>
-          <a:xfrm>
-            <a:off x="5916168" y="1353312"/>
-            <a:ext cx="237744" cy="164592"/>
-          </a:xfrm>
-          <a:prstGeom prst="rect">
-            <a:avLst/>
-          </a:prstGeom>
-          <a:solidFill>
-            <a:srgbClr val="8899AA"/>
-          </a:solidFill>
-          <a:ln w="12700">
-            <a:solidFill>
-              <a:srgbClr val="8899AA"/>
-            </a:solidFill>
-            <a:prstDash val="solid"/>
-          </a:ln>
-        </p:spPr>
-        <p:txBody>
-          <a:bodyPr/>
-          <a:lstStyle/>
-          <a:p>
-            <a:endParaRPr/>
-          </a:p>
-        </p:txBody>
-      </p:sp>
-      <p:sp>
-        <p:nvSpPr>
-          <p:cNvPr id="16" name="Text 14"/>
-          <p:cNvSpPr/>
-          <p:nvPr/>
-        </p:nvSpPr>
-        <p:spPr>
-          <a:xfrm>
-            <a:off x="2743200" y="2084832"/>
-            <a:ext cx="1371600" cy="274320"/>
-          </a:xfrm>
-          <a:prstGeom prst="rect">
-            <a:avLst/>
-          </a:prstGeom>
-          <a:noFill/>
-          <a:ln/>
-        </p:spPr>
-        <p:txBody>
-          <a:bodyPr wrap="square" lIns="0" tIns="0" rIns="0" bIns="0" rtlCol="0" anchor="ctr"/>
-          <a:lstStyle/>
-          <a:p>
-            <a:pPr marL="0" indent="0" algn="ctr">
-              <a:buNone/>
-            </a:pPr>
-            <a:r>
-              <a:rPr lang="en-US" sz="950" dirty="0">
-                <a:solidFill>
-                  <a:srgbClr val="8899AA"/>
-                </a:solidFill>
-              </a:rPr>
-              <a:t>같은 와이파이</a:t>
-            </a:r>
-            <a:endParaRPr lang="en-US" sz="950" dirty="0"/>
-          </a:p>
-        </p:txBody>
-      </p:sp>
-      <p:sp>
-        <p:nvSpPr>
-          <p:cNvPr id="17" name="Text 15"/>
-          <p:cNvSpPr/>
-          <p:nvPr/>
-        </p:nvSpPr>
-        <p:spPr>
-          <a:xfrm>
-            <a:off x="5669280" y="2084832"/>
-            <a:ext cx="914400" cy="274320"/>
-          </a:xfrm>
-          <a:prstGeom prst="rect">
-            <a:avLst/>
-          </a:prstGeom>
-          <a:noFill/>
-          <a:ln/>
-        </p:spPr>
-        <p:txBody>
-          <a:bodyPr wrap="square" lIns="0" tIns="0" rIns="0" bIns="0" rtlCol="0" anchor="ctr"/>
-          <a:lstStyle/>
-          <a:p>
-            <a:pPr marL="0" indent="0" algn="ctr">
-              <a:buNone/>
-            </a:pPr>
-            <a:r>
-              <a:rPr lang="en-US" sz="950" dirty="0">
-                <a:solidFill>
-                  <a:srgbClr val="8899AA"/>
-                </a:solidFill>
-              </a:rPr>
-              <a:t>HTTP</a:t>
-            </a:r>
-            <a:endParaRPr lang="en-US" sz="950" dirty="0"/>
-          </a:p>
-        </p:txBody>
-      </p:sp>
-      <p:sp>
-        <p:nvSpPr>
-          <p:cNvPr id="18" name="Shape 16"/>
-          <p:cNvSpPr/>
-          <p:nvPr/>
-        </p:nvSpPr>
-        <p:spPr>
-          <a:xfrm>
-            <a:off x="320040" y="2423160"/>
-            <a:ext cx="8503920" cy="2286000"/>
-          </a:xfrm>
-          <a:prstGeom prst="rect">
-            <a:avLst/>
-          </a:prstGeom>
-          <a:solidFill>
-            <a:srgbClr val="0D1117"/>
-          </a:solidFill>
-          <a:ln w="12700">
-            <a:solidFill>
-              <a:srgbClr val="30363D"/>
-            </a:solidFill>
-            <a:prstDash val="solid"/>
-          </a:ln>
-        </p:spPr>
-        <p:txBody>
-          <a:bodyPr/>
-          <a:lstStyle/>
-          <a:p>
-            <a:endParaRPr/>
-          </a:p>
-        </p:txBody>
-      </p:sp>
-      <p:sp>
-        <p:nvSpPr>
-          <p:cNvPr id="19" name="Text 17"/>
-          <p:cNvSpPr/>
-          <p:nvPr/>
-        </p:nvSpPr>
-        <p:spPr>
-          <a:xfrm>
-            <a:off x="502920" y="2487168"/>
-            <a:ext cx="8138160" cy="292608"/>
-          </a:xfrm>
-          <a:prstGeom prst="rect">
-            <a:avLst/>
-          </a:prstGeom>
-          <a:noFill/>
-          <a:ln/>
-        </p:spPr>
-        <p:txBody>
-          <a:bodyPr wrap="square" lIns="0" tIns="0" rIns="0" bIns="0" rtlCol="0" anchor="ctr"/>
-          <a:lstStyle/>
-          <a:p>
-            <a:pPr marL="0" indent="0">
-              <a:buNone/>
-            </a:pPr>
-            <a:r>
-              <a:rPr lang="en-US" sz="1100" dirty="0">
-                <a:solidFill>
-                  <a:srgbClr val="8B949E"/>
-                </a:solidFill>
-                <a:latin typeface="Courier New" pitchFamily="34" charset="0"/>
-                <a:ea typeface="Courier New" pitchFamily="34" charset="-122"/>
-                <a:cs typeface="Courier New" pitchFamily="34" charset="-120"/>
-              </a:rPr>
-              <a:t># 수강생 노트북 설정 (nb01 Step 0)</a:t>
-            </a:r>
-            <a:endParaRPr lang="en-US" sz="1100" dirty="0"/>
-          </a:p>
-        </p:txBody>
-      </p:sp>
-      <p:sp>
-        <p:nvSpPr>
-          <p:cNvPr id="20" name="Text 18"/>
-          <p:cNvSpPr/>
-          <p:nvPr/>
-        </p:nvSpPr>
-        <p:spPr>
-          <a:xfrm>
-            <a:off x="502920" y="2816352"/>
-            <a:ext cx="8138160" cy="347472"/>
-          </a:xfrm>
-          <a:prstGeom prst="rect">
-            <a:avLst/>
-          </a:prstGeom>
-          <a:noFill/>
-          <a:ln/>
-        </p:spPr>
-        <p:txBody>
-          <a:bodyPr wrap="square" lIns="0" tIns="0" rIns="0" bIns="0" rtlCol="0" anchor="ctr"/>
-          <a:lstStyle/>
-          <a:p>
-            <a:pPr marL="0" indent="0">
-              <a:buNone/>
-            </a:pPr>
-            <a:r>
-              <a:rPr lang="en-US" sz="1200" dirty="0">
-                <a:solidFill>
-                  <a:srgbClr val="79C0FF"/>
-                </a:solidFill>
-                <a:latin typeface="Courier New" pitchFamily="34" charset="0"/>
-                <a:ea typeface="Courier New" pitchFamily="34" charset="-122"/>
-                <a:cs typeface="Courier New" pitchFamily="34" charset="-120"/>
-              </a:rPr>
-              <a:t>INSTRUCTOR_IP    = </a:t>
-            </a:r>
-            <a:r>
-              <a:rPr lang="en-US" sz="1200" dirty="0">
-                <a:solidFill>
-                  <a:srgbClr val="FFB347"/>
-                </a:solidFill>
-                <a:latin typeface="Courier New" pitchFamily="34" charset="0"/>
-                <a:ea typeface="Courier New" pitchFamily="34" charset="-122"/>
-                <a:cs typeface="Courier New" pitchFamily="34" charset="-120"/>
-              </a:rPr>
-              <a:t>"</a:t>
-            </a:r>
-            <a:r>
-              <a:rPr lang="en-US" sz="1200" b="1" dirty="0">
-                <a:solidFill>
-                  <a:srgbClr val="FFB347"/>
-                </a:solidFill>
-                <a:latin typeface="Courier New" pitchFamily="34" charset="0"/>
-                <a:ea typeface="Courier New" pitchFamily="34" charset="-122"/>
-                <a:cs typeface="Courier New" pitchFamily="34" charset="-120"/>
-              </a:rPr>
-              <a:t>[강사가 공지한 IP]</a:t>
-            </a:r>
-            <a:r>
-              <a:rPr lang="en-US" sz="1200" dirty="0">
-                <a:solidFill>
-                  <a:srgbClr val="FFB347"/>
-                </a:solidFill>
-                <a:latin typeface="Courier New" pitchFamily="34" charset="0"/>
-                <a:ea typeface="Courier New" pitchFamily="34" charset="-122"/>
-                <a:cs typeface="Courier New" pitchFamily="34" charset="-120"/>
-              </a:rPr>
-              <a:t>"</a:t>
-            </a:r>
-            <a:endParaRPr lang="en-US" sz="1200" dirty="0"/>
-          </a:p>
-        </p:txBody>
-      </p:sp>
-      <p:sp>
-        <p:nvSpPr>
-          <p:cNvPr id="21" name="Text 19"/>
-          <p:cNvSpPr/>
-          <p:nvPr/>
-        </p:nvSpPr>
-        <p:spPr>
-          <a:xfrm>
-            <a:off x="502920" y="3200400"/>
-            <a:ext cx="8138160" cy="292608"/>
-          </a:xfrm>
-          <a:prstGeom prst="rect">
-            <a:avLst/>
-          </a:prstGeom>
-          <a:noFill/>
-          <a:ln/>
-        </p:spPr>
-        <p:txBody>
-          <a:bodyPr wrap="square" lIns="0" tIns="0" rIns="0" bIns="0" rtlCol="0" anchor="ctr"/>
-          <a:lstStyle/>
-          <a:p>
-            <a:pPr marL="0" indent="0">
-              <a:buNone/>
-            </a:pPr>
-            <a:r>
-              <a:rPr lang="en-US" sz="1200" dirty="0">
-                <a:solidFill>
-                  <a:srgbClr val="E6EDF3"/>
-                </a:solidFill>
-                <a:latin typeface="Courier New" pitchFamily="34" charset="0"/>
-                <a:ea typeface="Courier New" pitchFamily="34" charset="-122"/>
-                <a:cs typeface="Courier New" pitchFamily="34" charset="-120"/>
-              </a:rPr>
-              <a:t>LITELLM_BASE_URL = f"http://{INSTRUCTOR_IP}:4000/v1"</a:t>
-            </a:r>
-            <a:endParaRPr lang="en-US" sz="1200" dirty="0"/>
-          </a:p>
-        </p:txBody>
-      </p:sp>
-      <p:sp>
-        <p:nvSpPr>
-          <p:cNvPr id="22" name="Text 20"/>
-          <p:cNvSpPr/>
-          <p:nvPr/>
-        </p:nvSpPr>
-        <p:spPr>
-          <a:xfrm>
-            <a:off x="502920" y="3520440"/>
-            <a:ext cx="8138160" cy="292608"/>
-          </a:xfrm>
-          <a:prstGeom prst="rect">
-            <a:avLst/>
-          </a:prstGeom>
-          <a:noFill/>
-          <a:ln/>
-        </p:spPr>
-        <p:txBody>
-          <a:bodyPr wrap="square" lIns="0" tIns="0" rIns="0" bIns="0" rtlCol="0" anchor="ctr"/>
-          <a:lstStyle/>
-          <a:p>
-            <a:pPr marL="0" indent="0">
-              <a:buNone/>
-            </a:pPr>
-            <a:r>
-              <a:rPr lang="en-US" sz="1200" dirty="0">
-                <a:solidFill>
-                  <a:srgbClr val="E6EDF3"/>
-                </a:solidFill>
-                <a:latin typeface="Courier New" pitchFamily="34" charset="0"/>
-                <a:ea typeface="Courier New" pitchFamily="34" charset="-122"/>
-                <a:cs typeface="Courier New" pitchFamily="34" charset="-120"/>
-              </a:rPr>
-              <a:t>LITELLM_API_KEY  = "sk-workshop-2025"</a:t>
-            </a:r>
-            <a:endParaRPr lang="en-US" sz="1200" dirty="0"/>
-          </a:p>
-        </p:txBody>
-      </p:sp>
-      <p:sp>
-        <p:nvSpPr>
-          <p:cNvPr id="23" name="Text 21"/>
-          <p:cNvSpPr/>
-          <p:nvPr/>
-        </p:nvSpPr>
-        <p:spPr>
-          <a:xfrm>
-            <a:off x="502920" y="3840480"/>
-            <a:ext cx="8138160" cy="292608"/>
-          </a:xfrm>
-          <a:prstGeom prst="rect">
-            <a:avLst/>
-          </a:prstGeom>
-          <a:noFill/>
-          <a:ln/>
-        </p:spPr>
-        <p:txBody>
-          <a:bodyPr wrap="square" lIns="0" tIns="0" rIns="0" bIns="0" rtlCol="0" anchor="ctr"/>
-          <a:lstStyle/>
-          <a:p>
-            <a:pPr marL="0" indent="0">
-              <a:buNone/>
-            </a:pPr>
-            <a:r>
-              <a:rPr lang="en-US" sz="1200" dirty="0">
-                <a:solidFill>
-                  <a:srgbClr val="E6EDF3"/>
-                </a:solidFill>
-                <a:latin typeface="Courier New" pitchFamily="34" charset="0"/>
-                <a:ea typeface="Courier New" pitchFamily="34" charset="-122"/>
-                <a:cs typeface="Courier New" pitchFamily="34" charset="-120"/>
-              </a:rPr>
-              <a:t>MODEL_NAME       = "gemini-2.5-flash-lite"</a:t>
-            </a:r>
-            <a:endParaRPr lang="en-US" sz="1200" dirty="0"/>
-          </a:p>
-        </p:txBody>
-      </p:sp>
-    </p:spTree>
-  </p:cSld>
-  <p:clrMapOvr>
-    <a:masterClrMapping/>
-  </p:clrMapOvr>
-</p:sld>
-</file>
-
-<file path=ppt/slides/slide19.xml><?xml version="1.0" encoding="utf-8"?>
-<p:sld xmlns:a="http://schemas.openxmlformats.org/drawingml/2006/main" xmlns:r="http://schemas.openxmlformats.org/officeDocument/2006/relationships" xmlns:p="http://schemas.openxmlformats.org/presentationml/2006/main">
-  <p:cSld name="Slide 19">
-    <p:bg>
-      <p:bgPr>
-        <a:solidFill>
-          <a:srgbClr val="F4F6FB"/>
-        </a:solidFill>
-        <a:effectLst/>
-      </p:bgPr>
-    </p:bg>
-    <p:spTree>
-      <p:nvGrpSpPr>
-        <p:cNvPr id="1" name=""/>
-        <p:cNvGrpSpPr/>
-        <p:nvPr/>
-      </p:nvGrpSpPr>
-      <p:grpSpPr>
-        <a:xfrm>
-          <a:off x="0" y="0"/>
-          <a:ext cx="0" cy="0"/>
-          <a:chOff x="0" y="0"/>
-          <a:chExt cx="0" cy="0"/>
-        </a:xfrm>
-      </p:grpSpPr>
-      <p:sp>
-        <p:nvSpPr>
-          <p:cNvPr id="2" name="Shape 0"/>
-          <p:cNvSpPr/>
-          <p:nvPr/>
-        </p:nvSpPr>
-        <p:spPr>
-          <a:xfrm>
-            <a:off x="0" y="0"/>
-            <a:ext cx="9144000" cy="658368"/>
-          </a:xfrm>
-          <a:prstGeom prst="rect">
-            <a:avLst/>
-          </a:prstGeom>
-          <a:solidFill>
-            <a:srgbClr val="1A1F3A"/>
-          </a:solidFill>
-          <a:ln w="12700">
-            <a:solidFill>
-              <a:srgbClr val="1A1F3A"/>
-            </a:solidFill>
-            <a:prstDash val="solid"/>
-          </a:ln>
-        </p:spPr>
-        <p:txBody>
-          <a:bodyPr/>
-          <a:lstStyle/>
-          <a:p>
-            <a:endParaRPr/>
-          </a:p>
-        </p:txBody>
-      </p:sp>
-      <p:sp>
-        <p:nvSpPr>
-          <p:cNvPr id="3" name="Text 1"/>
-          <p:cNvSpPr/>
-          <p:nvPr/>
-        </p:nvSpPr>
-        <p:spPr>
-          <a:xfrm>
-            <a:off x="411480" y="91440"/>
-            <a:ext cx="8321040" cy="457200"/>
-          </a:xfrm>
-          <a:prstGeom prst="rect">
-            <a:avLst/>
-          </a:prstGeom>
-          <a:noFill/>
-          <a:ln/>
-        </p:spPr>
-        <p:txBody>
-          <a:bodyPr wrap="square" lIns="0" tIns="0" rIns="0" bIns="0" rtlCol="0" anchor="ctr"/>
-          <a:lstStyle/>
-          <a:p>
-            <a:pPr marL="0" indent="0">
-              <a:buNone/>
-            </a:pPr>
-            <a:r>
-              <a:rPr lang="en-US" sz="2000" b="1" dirty="0">
-                <a:solidFill>
-                  <a:srgbClr val="FFFFFF"/>
-                </a:solidFill>
-              </a:rPr>
-              <a:t>연결 트러블슈팅</a:t>
-            </a:r>
-            <a:endParaRPr lang="en-US" sz="2000" dirty="0"/>
-          </a:p>
-        </p:txBody>
-      </p:sp>
-      <p:sp>
-        <p:nvSpPr>
-          <p:cNvPr id="4" name="Text 2"/>
-          <p:cNvSpPr/>
-          <p:nvPr/>
-        </p:nvSpPr>
-        <p:spPr>
-          <a:xfrm>
-            <a:off x="411480" y="658368"/>
-            <a:ext cx="8321040" cy="292608"/>
-          </a:xfrm>
-          <a:prstGeom prst="rect">
-            <a:avLst/>
-          </a:prstGeom>
-          <a:noFill/>
-          <a:ln/>
-        </p:spPr>
-        <p:txBody>
-          <a:bodyPr wrap="square" lIns="0" tIns="0" rIns="0" bIns="0" rtlCol="0" anchor="ctr"/>
-          <a:lstStyle/>
-          <a:p>
-            <a:pPr marL="0" indent="0">
-              <a:buNone/>
-            </a:pPr>
-            <a:r>
-              <a:rPr lang="en-US" sz="1200" dirty="0">
-                <a:solidFill>
-                  <a:srgbClr val="8899AA"/>
-                </a:solidFill>
-              </a:rPr>
-              <a:t>오류 발생 시 여기서 확인</a:t>
-            </a:r>
-            <a:endParaRPr lang="en-US" sz="1200" dirty="0"/>
-          </a:p>
-        </p:txBody>
-      </p:sp>
-      <p:graphicFrame>
-        <p:nvGraphicFramePr>
-          <p:cNvPr id="20" name="Table 0"/>
-          <p:cNvGraphicFramePr>
-            <a:graphicFrameLocks noGrp="1"/>
-          </p:cNvGraphicFramePr>
-          <p:nvPr>
-            <p:extLst>
-              <p:ext uri="{D42A27DB-BD31-4B8C-83A1-F6EECF244321}">
-                <p14:modId xmlns:p14="http://schemas.microsoft.com/office/powerpoint/2010/main" val="1579011935"/>
-              </p:ext>
-            </p:extLst>
-          </p:nvPr>
-        </p:nvGraphicFramePr>
-        <p:xfrm>
-          <a:off x="320040" y="841248"/>
-          <a:ext cx="8503920" cy="3977640"/>
-        </p:xfrm>
-        <a:graphic>
-          <a:graphicData uri="http://schemas.openxmlformats.org/drawingml/2006/table">
-            <a:tbl>
-              <a:tblPr/>
-              <a:tblGrid>
-                <a:gridCol w="2194560">
-                  <a:extLst>
-                    <a:ext uri="{9D8B030D-6E8A-4147-A177-3AD203B41FA5}">
-                      <a16:colId xmlns:a16="http://schemas.microsoft.com/office/drawing/2014/main" val="20000"/>
-                    </a:ext>
-                  </a:extLst>
-                </a:gridCol>
-                <a:gridCol w="3017520">
-                  <a:extLst>
-                    <a:ext uri="{9D8B030D-6E8A-4147-A177-3AD203B41FA5}">
-                      <a16:colId xmlns:a16="http://schemas.microsoft.com/office/drawing/2014/main" val="20001"/>
-                    </a:ext>
-                  </a:extLst>
-                </a:gridCol>
-                <a:gridCol w="2926080">
-                  <a:extLst>
-                    <a:ext uri="{9D8B030D-6E8A-4147-A177-3AD203B41FA5}">
-                      <a16:colId xmlns:a16="http://schemas.microsoft.com/office/drawing/2014/main" val="20002"/>
-                    </a:ext>
-                  </a:extLst>
-                </a:gridCol>
-              </a:tblGrid>
-              <a:tr h="548640">
-                <a:tc>
-                  <a:txBody>
-                    <a:bodyPr/>
-                    <a:lstStyle/>
-                    <a:p>
-                      <a:pPr marL="0" indent="0" algn="l">
-                        <a:buNone/>
-                      </a:pPr>
-                      <a:r>
-                        <a:rPr lang="en-US" sz="1250" b="1" dirty="0">
-                          <a:solidFill>
-                            <a:srgbClr val="FFFFFF"/>
-                          </a:solidFill>
-                        </a:rPr>
-                        <a:t>오류 메시지</a:t>
-                      </a:r>
-                      <a:endParaRPr lang="en-US" sz="1250" dirty="0"/>
-                    </a:p>
-                  </a:txBody>
-                  <a:tcPr>
-                    <a:lnL w="6350" cap="flat" cmpd="sng" algn="ctr">
-                      <a:solidFill>
-                        <a:srgbClr val="DDE3F0"/>
-                      </a:solidFill>
-                      <a:prstDash val="solid"/>
-                      <a:round/>
-                      <a:headEnd type="none" w="med" len="med"/>
-                      <a:tailEnd type="none" w="med" len="med"/>
-                    </a:lnL>
-                    <a:lnR w="6350" cap="flat" cmpd="sng" algn="ctr">
-                      <a:solidFill>
-                        <a:srgbClr val="DDE3F0"/>
-                      </a:solidFill>
-                      <a:prstDash val="solid"/>
-                      <a:round/>
-                      <a:headEnd type="none" w="med" len="med"/>
-                      <a:tailEnd type="none" w="med" len="med"/>
-                    </a:lnR>
-                    <a:lnT w="6350" cap="flat" cmpd="sng" algn="ctr">
-                      <a:solidFill>
-                        <a:srgbClr val="DDE3F0"/>
-                      </a:solidFill>
-                      <a:prstDash val="solid"/>
-                      <a:round/>
-                      <a:headEnd type="none" w="med" len="med"/>
-                      <a:tailEnd type="none" w="med" len="med"/>
-                    </a:lnT>
-                    <a:lnB w="6350" cap="flat" cmpd="sng" algn="ctr">
-                      <a:solidFill>
-                        <a:srgbClr val="DDE3F0"/>
-                      </a:solidFill>
-                      <a:prstDash val="solid"/>
-                      <a:round/>
-                      <a:headEnd type="none" w="med" len="med"/>
-                      <a:tailEnd type="none" w="med" len="med"/>
-                    </a:lnB>
-                    <a:solidFill>
-                      <a:srgbClr val="1A1F3A"/>
-                    </a:solidFill>
-                  </a:tcPr>
-                </a:tc>
-                <a:tc>
-                  <a:txBody>
-                    <a:bodyPr/>
-                    <a:lstStyle/>
-                    <a:p>
-                      <a:pPr marL="0" indent="0" algn="l">
-                        <a:buNone/>
-                      </a:pPr>
-                      <a:r>
-                        <a:rPr lang="en-US" sz="1250" b="1" dirty="0">
-                          <a:solidFill>
-                            <a:srgbClr val="FFFFFF"/>
-                          </a:solidFill>
-                        </a:rPr>
-                        <a:t>원인</a:t>
-                      </a:r>
-                      <a:endParaRPr lang="en-US" sz="1250" dirty="0"/>
-                    </a:p>
-                  </a:txBody>
-                  <a:tcPr>
-                    <a:lnL w="6350" cap="flat" cmpd="sng" algn="ctr">
-                      <a:solidFill>
-                        <a:srgbClr val="DDE3F0"/>
-                      </a:solidFill>
-                      <a:prstDash val="solid"/>
-                      <a:round/>
-                      <a:headEnd type="none" w="med" len="med"/>
-                      <a:tailEnd type="none" w="med" len="med"/>
-                    </a:lnL>
-                    <a:lnR w="6350" cap="flat" cmpd="sng" algn="ctr">
-                      <a:solidFill>
-                        <a:srgbClr val="DDE3F0"/>
-                      </a:solidFill>
-                      <a:prstDash val="solid"/>
-                      <a:round/>
-                      <a:headEnd type="none" w="med" len="med"/>
-                      <a:tailEnd type="none" w="med" len="med"/>
-                    </a:lnR>
-                    <a:lnT w="6350" cap="flat" cmpd="sng" algn="ctr">
-                      <a:solidFill>
-                        <a:srgbClr val="DDE3F0"/>
-                      </a:solidFill>
-                      <a:prstDash val="solid"/>
-                      <a:round/>
-                      <a:headEnd type="none" w="med" len="med"/>
-                      <a:tailEnd type="none" w="med" len="med"/>
-                    </a:lnT>
-                    <a:lnB w="6350" cap="flat" cmpd="sng" algn="ctr">
-                      <a:solidFill>
-                        <a:srgbClr val="DDE3F0"/>
-                      </a:solidFill>
-                      <a:prstDash val="solid"/>
-                      <a:round/>
-                      <a:headEnd type="none" w="med" len="med"/>
-                      <a:tailEnd type="none" w="med" len="med"/>
-                    </a:lnB>
-                    <a:solidFill>
-                      <a:srgbClr val="1A1F3A"/>
-                    </a:solidFill>
-                  </a:tcPr>
-                </a:tc>
-                <a:tc>
-                  <a:txBody>
-                    <a:bodyPr/>
-                    <a:lstStyle/>
-                    <a:p>
-                      <a:pPr marL="0" indent="0" algn="l">
-                        <a:buNone/>
-                      </a:pPr>
-                      <a:r>
-                        <a:rPr lang="en-US" sz="1250" b="1" dirty="0">
-                          <a:solidFill>
-                            <a:srgbClr val="FFFFFF"/>
-                          </a:solidFill>
-                        </a:rPr>
-                        <a:t>해결 방법</a:t>
-                      </a:r>
-                      <a:endParaRPr lang="en-US" sz="1250" dirty="0"/>
-                    </a:p>
-                  </a:txBody>
-                  <a:tcPr>
-                    <a:lnL w="6350" cap="flat" cmpd="sng" algn="ctr">
-                      <a:solidFill>
-                        <a:srgbClr val="DDE3F0"/>
-                      </a:solidFill>
-                      <a:prstDash val="solid"/>
-                      <a:round/>
-                      <a:headEnd type="none" w="med" len="med"/>
-                      <a:tailEnd type="none" w="med" len="med"/>
-                    </a:lnL>
-                    <a:lnR w="6350" cap="flat" cmpd="sng" algn="ctr">
-                      <a:solidFill>
-                        <a:srgbClr val="DDE3F0"/>
-                      </a:solidFill>
-                      <a:prstDash val="solid"/>
-                      <a:round/>
-                      <a:headEnd type="none" w="med" len="med"/>
-                      <a:tailEnd type="none" w="med" len="med"/>
-                    </a:lnR>
-                    <a:lnT w="6350" cap="flat" cmpd="sng" algn="ctr">
-                      <a:solidFill>
-                        <a:srgbClr val="DDE3F0"/>
-                      </a:solidFill>
-                      <a:prstDash val="solid"/>
-                      <a:round/>
-                      <a:headEnd type="none" w="med" len="med"/>
-                      <a:tailEnd type="none" w="med" len="med"/>
-                    </a:lnT>
-                    <a:lnB w="6350" cap="flat" cmpd="sng" algn="ctr">
-                      <a:solidFill>
-                        <a:srgbClr val="DDE3F0"/>
-                      </a:solidFill>
-                      <a:prstDash val="solid"/>
-                      <a:round/>
-                      <a:headEnd type="none" w="med" len="med"/>
-                      <a:tailEnd type="none" w="med" len="med"/>
-                    </a:lnB>
-                    <a:solidFill>
-                      <a:srgbClr val="1A1F3A"/>
-                    </a:solidFill>
-                  </a:tcPr>
-                </a:tc>
-                <a:extLst>
-                  <a:ext uri="{0D108BD9-81ED-4DB2-BD59-A6C34878D82A}">
-                    <a16:rowId xmlns:a16="http://schemas.microsoft.com/office/drawing/2014/main" val="10000"/>
-                  </a:ext>
-                </a:extLst>
-              </a:tr>
-              <a:tr h="548640">
-                <a:tc>
-                  <a:txBody>
-                    <a:bodyPr/>
-                    <a:lstStyle/>
-                    <a:p>
-                      <a:pPr marL="0" indent="0" algn="l">
-                        <a:buNone/>
-                      </a:pPr>
-                      <a:r>
-                        <a:rPr lang="en-US" sz="1250" dirty="0">
-                          <a:solidFill>
-                            <a:srgbClr val="000000"/>
-                          </a:solidFill>
-                        </a:rPr>
-                        <a:t>Connection refused</a:t>
-                      </a:r>
-                      <a:endParaRPr lang="en-US" sz="1250" dirty="0"/>
-                    </a:p>
-                  </a:txBody>
-                  <a:tcPr>
-                    <a:lnL w="6350" cap="flat" cmpd="sng" algn="ctr">
-                      <a:solidFill>
-                        <a:srgbClr val="DDE3F0"/>
-                      </a:solidFill>
-                      <a:prstDash val="solid"/>
-                      <a:round/>
-                      <a:headEnd type="none" w="med" len="med"/>
-                      <a:tailEnd type="none" w="med" len="med"/>
-                    </a:lnL>
-                    <a:lnR w="6350" cap="flat" cmpd="sng" algn="ctr">
-                      <a:solidFill>
-                        <a:srgbClr val="DDE3F0"/>
-                      </a:solidFill>
-                      <a:prstDash val="solid"/>
-                      <a:round/>
-                      <a:headEnd type="none" w="med" len="med"/>
-                      <a:tailEnd type="none" w="med" len="med"/>
-                    </a:lnR>
-                    <a:lnT w="6350" cap="flat" cmpd="sng" algn="ctr">
-                      <a:solidFill>
-                        <a:srgbClr val="DDE3F0"/>
-                      </a:solidFill>
-                      <a:prstDash val="solid"/>
-                      <a:round/>
-                      <a:headEnd type="none" w="med" len="med"/>
-                      <a:tailEnd type="none" w="med" len="med"/>
-                    </a:lnT>
-                    <a:lnB w="6350" cap="flat" cmpd="sng" algn="ctr">
-                      <a:solidFill>
-                        <a:srgbClr val="DDE3F0"/>
-                      </a:solidFill>
-                      <a:prstDash val="solid"/>
-                      <a:round/>
-                      <a:headEnd type="none" w="med" len="med"/>
-                      <a:tailEnd type="none" w="med" len="med"/>
-                    </a:lnB>
-                  </a:tcPr>
-                </a:tc>
-                <a:tc>
-                  <a:txBody>
-                    <a:bodyPr/>
-                    <a:lstStyle/>
-                    <a:p>
-                      <a:pPr marL="0" indent="0" algn="l">
-                        <a:buNone/>
-                      </a:pPr>
-                      <a:r>
-                        <a:rPr lang="en-US" sz="1250" dirty="0">
-                          <a:solidFill>
-                            <a:srgbClr val="000000"/>
-                          </a:solidFill>
-                        </a:rPr>
-                        <a:t>IP 주소 오류 또는 proxy 미실행</a:t>
-                      </a:r>
-                      <a:endParaRPr lang="en-US" sz="1250" dirty="0"/>
-                    </a:p>
-                  </a:txBody>
-                  <a:tcPr>
-                    <a:lnL w="6350" cap="flat" cmpd="sng" algn="ctr">
-                      <a:solidFill>
-                        <a:srgbClr val="DDE3F0"/>
-                      </a:solidFill>
-                      <a:prstDash val="solid"/>
-                      <a:round/>
-                      <a:headEnd type="none" w="med" len="med"/>
-                      <a:tailEnd type="none" w="med" len="med"/>
-                    </a:lnL>
-                    <a:lnR w="6350" cap="flat" cmpd="sng" algn="ctr">
-                      <a:solidFill>
-                        <a:srgbClr val="DDE3F0"/>
-                      </a:solidFill>
-                      <a:prstDash val="solid"/>
-                      <a:round/>
-                      <a:headEnd type="none" w="med" len="med"/>
-                      <a:tailEnd type="none" w="med" len="med"/>
-                    </a:lnR>
-                    <a:lnT w="6350" cap="flat" cmpd="sng" algn="ctr">
-                      <a:solidFill>
-                        <a:srgbClr val="DDE3F0"/>
-                      </a:solidFill>
-                      <a:prstDash val="solid"/>
-                      <a:round/>
-                      <a:headEnd type="none" w="med" len="med"/>
-                      <a:tailEnd type="none" w="med" len="med"/>
-                    </a:lnT>
-                    <a:lnB w="6350" cap="flat" cmpd="sng" algn="ctr">
-                      <a:solidFill>
-                        <a:srgbClr val="DDE3F0"/>
-                      </a:solidFill>
-                      <a:prstDash val="solid"/>
-                      <a:round/>
-                      <a:headEnd type="none" w="med" len="med"/>
-                      <a:tailEnd type="none" w="med" len="med"/>
-                    </a:lnB>
-                  </a:tcPr>
-                </a:tc>
-                <a:tc>
-                  <a:txBody>
-                    <a:bodyPr/>
-                    <a:lstStyle/>
-                    <a:p>
-                      <a:pPr marL="0" indent="0" algn="l">
-                        <a:buNone/>
-                      </a:pPr>
-                      <a:r>
-                        <a:rPr lang="en-US" sz="1250" dirty="0">
-                          <a:solidFill>
-                            <a:srgbClr val="000000"/>
-                          </a:solidFill>
-                        </a:rPr>
-                        <a:t>IP 재확인 후 강사에게 문의</a:t>
-                      </a:r>
-                      <a:endParaRPr lang="en-US" sz="1250" dirty="0"/>
-                    </a:p>
-                  </a:txBody>
-                  <a:tcPr>
-                    <a:lnL w="6350" cap="flat" cmpd="sng" algn="ctr">
-                      <a:solidFill>
-                        <a:srgbClr val="DDE3F0"/>
-                      </a:solidFill>
-                      <a:prstDash val="solid"/>
-                      <a:round/>
-                      <a:headEnd type="none" w="med" len="med"/>
-                      <a:tailEnd type="none" w="med" len="med"/>
-                    </a:lnL>
-                    <a:lnR w="6350" cap="flat" cmpd="sng" algn="ctr">
-                      <a:solidFill>
-                        <a:srgbClr val="DDE3F0"/>
-                      </a:solidFill>
-                      <a:prstDash val="solid"/>
-                      <a:round/>
-                      <a:headEnd type="none" w="med" len="med"/>
-                      <a:tailEnd type="none" w="med" len="med"/>
-                    </a:lnR>
-                    <a:lnT w="6350" cap="flat" cmpd="sng" algn="ctr">
-                      <a:solidFill>
-                        <a:srgbClr val="DDE3F0"/>
-                      </a:solidFill>
-                      <a:prstDash val="solid"/>
-                      <a:round/>
-                      <a:headEnd type="none" w="med" len="med"/>
-                      <a:tailEnd type="none" w="med" len="med"/>
-                    </a:lnT>
-                    <a:lnB w="6350" cap="flat" cmpd="sng" algn="ctr">
-                      <a:solidFill>
-                        <a:srgbClr val="DDE3F0"/>
-                      </a:solidFill>
-                      <a:prstDash val="solid"/>
-                      <a:round/>
-                      <a:headEnd type="none" w="med" len="med"/>
-                      <a:tailEnd type="none" w="med" len="med"/>
-                    </a:lnB>
-                  </a:tcPr>
-                </a:tc>
-                <a:extLst>
-                  <a:ext uri="{0D108BD9-81ED-4DB2-BD59-A6C34878D82A}">
-                    <a16:rowId xmlns:a16="http://schemas.microsoft.com/office/drawing/2014/main" val="10001"/>
-                  </a:ext>
-                </a:extLst>
-              </a:tr>
-              <a:tr h="548640">
-                <a:tc>
-                  <a:txBody>
-                    <a:bodyPr/>
-                    <a:lstStyle/>
-                    <a:p>
-                      <a:pPr marL="0" indent="0" algn="l">
-                        <a:buNone/>
-                      </a:pPr>
-                      <a:r>
-                        <a:rPr lang="en-US" sz="1250" dirty="0">
-                          <a:solidFill>
-                            <a:srgbClr val="000000"/>
-                          </a:solidFill>
-                        </a:rPr>
-                        <a:t>ConnectTimeout</a:t>
-                      </a:r>
-                      <a:endParaRPr lang="en-US" sz="1250" dirty="0"/>
-                    </a:p>
-                  </a:txBody>
-                  <a:tcPr>
-                    <a:lnL w="6350" cap="flat" cmpd="sng" algn="ctr">
-                      <a:solidFill>
-                        <a:srgbClr val="DDE3F0"/>
-                      </a:solidFill>
-                      <a:prstDash val="solid"/>
-                      <a:round/>
-                      <a:headEnd type="none" w="med" len="med"/>
-                      <a:tailEnd type="none" w="med" len="med"/>
-                    </a:lnL>
-                    <a:lnR w="6350" cap="flat" cmpd="sng" algn="ctr">
-                      <a:solidFill>
-                        <a:srgbClr val="DDE3F0"/>
-                      </a:solidFill>
-                      <a:prstDash val="solid"/>
-                      <a:round/>
-                      <a:headEnd type="none" w="med" len="med"/>
-                      <a:tailEnd type="none" w="med" len="med"/>
-                    </a:lnR>
-                    <a:lnT w="6350" cap="flat" cmpd="sng" algn="ctr">
-                      <a:solidFill>
-                        <a:srgbClr val="DDE3F0"/>
-                      </a:solidFill>
-                      <a:prstDash val="solid"/>
-                      <a:round/>
-                      <a:headEnd type="none" w="med" len="med"/>
-                      <a:tailEnd type="none" w="med" len="med"/>
-                    </a:lnT>
-                    <a:lnB w="6350" cap="flat" cmpd="sng" algn="ctr">
-                      <a:solidFill>
-                        <a:srgbClr val="DDE3F0"/>
-                      </a:solidFill>
-                      <a:prstDash val="solid"/>
-                      <a:round/>
-                      <a:headEnd type="none" w="med" len="med"/>
-                      <a:tailEnd type="none" w="med" len="med"/>
-                    </a:lnB>
-                  </a:tcPr>
-                </a:tc>
-                <a:tc>
-                  <a:txBody>
-                    <a:bodyPr/>
-                    <a:lstStyle/>
-                    <a:p>
-                      <a:pPr marL="0" indent="0" algn="l">
-                        <a:buNone/>
-                      </a:pPr>
-                      <a:r>
-                        <a:rPr lang="en-US" sz="1250" dirty="0">
-                          <a:solidFill>
-                            <a:srgbClr val="000000"/>
-                          </a:solidFill>
-                        </a:rPr>
-                        <a:t>와이파이 불일치</a:t>
-                      </a:r>
-                      <a:endParaRPr lang="en-US" sz="1250" dirty="0"/>
-                    </a:p>
-                  </a:txBody>
-                  <a:tcPr>
-                    <a:lnL w="6350" cap="flat" cmpd="sng" algn="ctr">
-                      <a:solidFill>
-                        <a:srgbClr val="DDE3F0"/>
-                      </a:solidFill>
-                      <a:prstDash val="solid"/>
-                      <a:round/>
-                      <a:headEnd type="none" w="med" len="med"/>
-                      <a:tailEnd type="none" w="med" len="med"/>
-                    </a:lnL>
-                    <a:lnR w="6350" cap="flat" cmpd="sng" algn="ctr">
-                      <a:solidFill>
-                        <a:srgbClr val="DDE3F0"/>
-                      </a:solidFill>
-                      <a:prstDash val="solid"/>
-                      <a:round/>
-                      <a:headEnd type="none" w="med" len="med"/>
-                      <a:tailEnd type="none" w="med" len="med"/>
-                    </a:lnR>
-                    <a:lnT w="6350" cap="flat" cmpd="sng" algn="ctr">
-                      <a:solidFill>
-                        <a:srgbClr val="DDE3F0"/>
-                      </a:solidFill>
-                      <a:prstDash val="solid"/>
-                      <a:round/>
-                      <a:headEnd type="none" w="med" len="med"/>
-                      <a:tailEnd type="none" w="med" len="med"/>
-                    </a:lnT>
-                    <a:lnB w="6350" cap="flat" cmpd="sng" algn="ctr">
-                      <a:solidFill>
-                        <a:srgbClr val="DDE3F0"/>
-                      </a:solidFill>
-                      <a:prstDash val="solid"/>
-                      <a:round/>
-                      <a:headEnd type="none" w="med" len="med"/>
-                      <a:tailEnd type="none" w="med" len="med"/>
-                    </a:lnB>
-                  </a:tcPr>
-                </a:tc>
-                <a:tc>
-                  <a:txBody>
-                    <a:bodyPr/>
-                    <a:lstStyle/>
-                    <a:p>
-                      <a:pPr marL="0" indent="0" algn="l">
-                        <a:buNone/>
-                      </a:pPr>
-                      <a:r>
-                        <a:rPr lang="en-US" sz="1250" dirty="0">
-                          <a:solidFill>
-                            <a:srgbClr val="000000"/>
-                          </a:solidFill>
-                        </a:rPr>
-                        <a:t>강사와 동일한 와이파이에 연결</a:t>
-                      </a:r>
-                      <a:endParaRPr lang="en-US" sz="1250" dirty="0"/>
-                    </a:p>
-                  </a:txBody>
-                  <a:tcPr>
-                    <a:lnL w="6350" cap="flat" cmpd="sng" algn="ctr">
-                      <a:solidFill>
-                        <a:srgbClr val="DDE3F0"/>
-                      </a:solidFill>
-                      <a:prstDash val="solid"/>
-                      <a:round/>
-                      <a:headEnd type="none" w="med" len="med"/>
-                      <a:tailEnd type="none" w="med" len="med"/>
-                    </a:lnL>
-                    <a:lnR w="6350" cap="flat" cmpd="sng" algn="ctr">
-                      <a:solidFill>
-                        <a:srgbClr val="DDE3F0"/>
-                      </a:solidFill>
-                      <a:prstDash val="solid"/>
-                      <a:round/>
-                      <a:headEnd type="none" w="med" len="med"/>
-                      <a:tailEnd type="none" w="med" len="med"/>
-                    </a:lnR>
-                    <a:lnT w="6350" cap="flat" cmpd="sng" algn="ctr">
-                      <a:solidFill>
-                        <a:srgbClr val="DDE3F0"/>
-                      </a:solidFill>
-                      <a:prstDash val="solid"/>
-                      <a:round/>
-                      <a:headEnd type="none" w="med" len="med"/>
-                      <a:tailEnd type="none" w="med" len="med"/>
-                    </a:lnT>
-                    <a:lnB w="6350" cap="flat" cmpd="sng" algn="ctr">
-                      <a:solidFill>
-                        <a:srgbClr val="DDE3F0"/>
-                      </a:solidFill>
-                      <a:prstDash val="solid"/>
-                      <a:round/>
-                      <a:headEnd type="none" w="med" len="med"/>
-                      <a:tailEnd type="none" w="med" len="med"/>
-                    </a:lnB>
-                  </a:tcPr>
-                </a:tc>
-                <a:extLst>
-                  <a:ext uri="{0D108BD9-81ED-4DB2-BD59-A6C34878D82A}">
-                    <a16:rowId xmlns:a16="http://schemas.microsoft.com/office/drawing/2014/main" val="10002"/>
-                  </a:ext>
-                </a:extLst>
-              </a:tr>
-              <a:tr h="548640">
-                <a:tc>
-                  <a:txBody>
-                    <a:bodyPr/>
-                    <a:lstStyle/>
-                    <a:p>
-                      <a:pPr marL="0" indent="0" algn="l">
-                        <a:buNone/>
-                      </a:pPr>
-                      <a:r>
-                        <a:rPr lang="en-US" sz="1250" dirty="0">
-                          <a:solidFill>
-                            <a:srgbClr val="000000"/>
-                          </a:solidFill>
-                        </a:rPr>
-                        <a:t>401 Unauthorized</a:t>
-                      </a:r>
-                      <a:endParaRPr lang="en-US" sz="1250" dirty="0"/>
-                    </a:p>
-                  </a:txBody>
-                  <a:tcPr>
-                    <a:lnL w="6350" cap="flat" cmpd="sng" algn="ctr">
-                      <a:solidFill>
-                        <a:srgbClr val="DDE3F0"/>
-                      </a:solidFill>
-                      <a:prstDash val="solid"/>
-                      <a:round/>
-                      <a:headEnd type="none" w="med" len="med"/>
-                      <a:tailEnd type="none" w="med" len="med"/>
-                    </a:lnL>
-                    <a:lnR w="6350" cap="flat" cmpd="sng" algn="ctr">
-                      <a:solidFill>
-                        <a:srgbClr val="DDE3F0"/>
-                      </a:solidFill>
-                      <a:prstDash val="solid"/>
-                      <a:round/>
-                      <a:headEnd type="none" w="med" len="med"/>
-                      <a:tailEnd type="none" w="med" len="med"/>
-                    </a:lnR>
-                    <a:lnT w="6350" cap="flat" cmpd="sng" algn="ctr">
-                      <a:solidFill>
-                        <a:srgbClr val="DDE3F0"/>
-                      </a:solidFill>
-                      <a:prstDash val="solid"/>
-                      <a:round/>
-                      <a:headEnd type="none" w="med" len="med"/>
-                      <a:tailEnd type="none" w="med" len="med"/>
-                    </a:lnT>
-                    <a:lnB w="6350" cap="flat" cmpd="sng" algn="ctr">
-                      <a:solidFill>
-                        <a:srgbClr val="DDE3F0"/>
-                      </a:solidFill>
-                      <a:prstDash val="solid"/>
-                      <a:round/>
-                      <a:headEnd type="none" w="med" len="med"/>
-                      <a:tailEnd type="none" w="med" len="med"/>
-                    </a:lnB>
-                  </a:tcPr>
-                </a:tc>
-                <a:tc>
-                  <a:txBody>
-                    <a:bodyPr/>
-                    <a:lstStyle/>
-                    <a:p>
-                      <a:pPr marL="0" indent="0" algn="l">
-                        <a:buNone/>
-                      </a:pPr>
-                      <a:r>
-                        <a:rPr lang="en-US" sz="1250" dirty="0">
-                          <a:solidFill>
-                            <a:srgbClr val="000000"/>
-                          </a:solidFill>
-                        </a:rPr>
-                        <a:t>API key 오류</a:t>
-                      </a:r>
-                      <a:endParaRPr lang="en-US" sz="1250" dirty="0"/>
-                    </a:p>
-                  </a:txBody>
-                  <a:tcPr>
-                    <a:lnL w="6350" cap="flat" cmpd="sng" algn="ctr">
-                      <a:solidFill>
-                        <a:srgbClr val="DDE3F0"/>
-                      </a:solidFill>
-                      <a:prstDash val="solid"/>
-                      <a:round/>
-                      <a:headEnd type="none" w="med" len="med"/>
-                      <a:tailEnd type="none" w="med" len="med"/>
-                    </a:lnL>
-                    <a:lnR w="6350" cap="flat" cmpd="sng" algn="ctr">
-                      <a:solidFill>
-                        <a:srgbClr val="DDE3F0"/>
-                      </a:solidFill>
-                      <a:prstDash val="solid"/>
-                      <a:round/>
-                      <a:headEnd type="none" w="med" len="med"/>
-                      <a:tailEnd type="none" w="med" len="med"/>
-                    </a:lnR>
-                    <a:lnT w="6350" cap="flat" cmpd="sng" algn="ctr">
-                      <a:solidFill>
-                        <a:srgbClr val="DDE3F0"/>
-                      </a:solidFill>
-                      <a:prstDash val="solid"/>
-                      <a:round/>
-                      <a:headEnd type="none" w="med" len="med"/>
-                      <a:tailEnd type="none" w="med" len="med"/>
-                    </a:lnT>
-                    <a:lnB w="6350" cap="flat" cmpd="sng" algn="ctr">
-                      <a:solidFill>
-                        <a:srgbClr val="DDE3F0"/>
-                      </a:solidFill>
-                      <a:prstDash val="solid"/>
-                      <a:round/>
-                      <a:headEnd type="none" w="med" len="med"/>
-                      <a:tailEnd type="none" w="med" len="med"/>
-                    </a:lnB>
-                  </a:tcPr>
-                </a:tc>
-                <a:tc>
-                  <a:txBody>
-                    <a:bodyPr/>
-                    <a:lstStyle/>
-                    <a:p>
-                      <a:pPr marL="0" indent="0" algn="l">
-                        <a:buNone/>
-                      </a:pPr>
-                      <a:r>
-                        <a:rPr lang="en-US" sz="1250" dirty="0">
-                          <a:solidFill>
-                            <a:srgbClr val="000000"/>
-                          </a:solidFill>
-                        </a:rPr>
-                        <a:t>"sk-workshop-2025" 정확히 입력</a:t>
-                      </a:r>
-                      <a:endParaRPr lang="en-US" sz="1250" dirty="0"/>
-                    </a:p>
-                  </a:txBody>
-                  <a:tcPr>
-                    <a:lnL w="6350" cap="flat" cmpd="sng" algn="ctr">
-                      <a:solidFill>
-                        <a:srgbClr val="DDE3F0"/>
-                      </a:solidFill>
-                      <a:prstDash val="solid"/>
-                      <a:round/>
-                      <a:headEnd type="none" w="med" len="med"/>
-                      <a:tailEnd type="none" w="med" len="med"/>
-                    </a:lnL>
-                    <a:lnR w="6350" cap="flat" cmpd="sng" algn="ctr">
-                      <a:solidFill>
-                        <a:srgbClr val="DDE3F0"/>
-                      </a:solidFill>
-                      <a:prstDash val="solid"/>
-                      <a:round/>
-                      <a:headEnd type="none" w="med" len="med"/>
-                      <a:tailEnd type="none" w="med" len="med"/>
-                    </a:lnR>
-                    <a:lnT w="6350" cap="flat" cmpd="sng" algn="ctr">
-                      <a:solidFill>
-                        <a:srgbClr val="DDE3F0"/>
-                      </a:solidFill>
-                      <a:prstDash val="solid"/>
-                      <a:round/>
-                      <a:headEnd type="none" w="med" len="med"/>
-                      <a:tailEnd type="none" w="med" len="med"/>
-                    </a:lnT>
-                    <a:lnB w="6350" cap="flat" cmpd="sng" algn="ctr">
-                      <a:solidFill>
-                        <a:srgbClr val="DDE3F0"/>
-                      </a:solidFill>
-                      <a:prstDash val="solid"/>
-                      <a:round/>
-                      <a:headEnd type="none" w="med" len="med"/>
-                      <a:tailEnd type="none" w="med" len="med"/>
-                    </a:lnB>
-                  </a:tcPr>
-                </a:tc>
-                <a:extLst>
-                  <a:ext uri="{0D108BD9-81ED-4DB2-BD59-A6C34878D82A}">
-                    <a16:rowId xmlns:a16="http://schemas.microsoft.com/office/drawing/2014/main" val="10003"/>
-                  </a:ext>
-                </a:extLst>
-              </a:tr>
-              <a:tr h="548640">
-                <a:tc>
-                  <a:txBody>
-                    <a:bodyPr/>
-                    <a:lstStyle/>
-                    <a:p>
-                      <a:pPr marL="0" indent="0" algn="l">
-                        <a:buNone/>
-                      </a:pPr>
-                      <a:r>
-                        <a:rPr lang="en-US" sz="1250" dirty="0">
-                          <a:solidFill>
-                            <a:srgbClr val="000000"/>
-                          </a:solidFill>
-                        </a:rPr>
-                        <a:t>404 Not Found</a:t>
-                      </a:r>
-                      <a:endParaRPr lang="en-US" sz="1250" dirty="0"/>
-                    </a:p>
-                  </a:txBody>
-                  <a:tcPr>
-                    <a:lnL w="6350" cap="flat" cmpd="sng" algn="ctr">
-                      <a:solidFill>
-                        <a:srgbClr val="DDE3F0"/>
-                      </a:solidFill>
-                      <a:prstDash val="solid"/>
-                      <a:round/>
-                      <a:headEnd type="none" w="med" len="med"/>
-                      <a:tailEnd type="none" w="med" len="med"/>
-                    </a:lnL>
-                    <a:lnR w="6350" cap="flat" cmpd="sng" algn="ctr">
-                      <a:solidFill>
-                        <a:srgbClr val="DDE3F0"/>
-                      </a:solidFill>
-                      <a:prstDash val="solid"/>
-                      <a:round/>
-                      <a:headEnd type="none" w="med" len="med"/>
-                      <a:tailEnd type="none" w="med" len="med"/>
-                    </a:lnR>
-                    <a:lnT w="6350" cap="flat" cmpd="sng" algn="ctr">
-                      <a:solidFill>
-                        <a:srgbClr val="DDE3F0"/>
-                      </a:solidFill>
-                      <a:prstDash val="solid"/>
-                      <a:round/>
-                      <a:headEnd type="none" w="med" len="med"/>
-                      <a:tailEnd type="none" w="med" len="med"/>
-                    </a:lnT>
-                    <a:lnB w="6350" cap="flat" cmpd="sng" algn="ctr">
-                      <a:solidFill>
-                        <a:srgbClr val="DDE3F0"/>
-                      </a:solidFill>
-                      <a:prstDash val="solid"/>
-                      <a:round/>
-                      <a:headEnd type="none" w="med" len="med"/>
-                      <a:tailEnd type="none" w="med" len="med"/>
-                    </a:lnB>
-                  </a:tcPr>
-                </a:tc>
-                <a:tc>
-                  <a:txBody>
-                    <a:bodyPr/>
-                    <a:lstStyle/>
-                    <a:p>
-                      <a:pPr marL="0" indent="0" algn="l">
-                        <a:buNone/>
-                      </a:pPr>
-                      <a:r>
-                        <a:rPr lang="en-US" sz="1250" dirty="0">
-                          <a:solidFill>
-                            <a:srgbClr val="000000"/>
-                          </a:solidFill>
-                        </a:rPr>
-                        <a:t>URL 경로 오류</a:t>
-                      </a:r>
-                      <a:endParaRPr lang="en-US" sz="1250" dirty="0"/>
-                    </a:p>
-                  </a:txBody>
-                  <a:tcPr>
-                    <a:lnL w="6350" cap="flat" cmpd="sng" algn="ctr">
-                      <a:solidFill>
-                        <a:srgbClr val="DDE3F0"/>
-                      </a:solidFill>
-                      <a:prstDash val="solid"/>
-                      <a:round/>
-                      <a:headEnd type="none" w="med" len="med"/>
-                      <a:tailEnd type="none" w="med" len="med"/>
-                    </a:lnL>
-                    <a:lnR w="6350" cap="flat" cmpd="sng" algn="ctr">
-                      <a:solidFill>
-                        <a:srgbClr val="DDE3F0"/>
-                      </a:solidFill>
-                      <a:prstDash val="solid"/>
-                      <a:round/>
-                      <a:headEnd type="none" w="med" len="med"/>
-                      <a:tailEnd type="none" w="med" len="med"/>
-                    </a:lnR>
-                    <a:lnT w="6350" cap="flat" cmpd="sng" algn="ctr">
-                      <a:solidFill>
-                        <a:srgbClr val="DDE3F0"/>
-                      </a:solidFill>
-                      <a:prstDash val="solid"/>
-                      <a:round/>
-                      <a:headEnd type="none" w="med" len="med"/>
-                      <a:tailEnd type="none" w="med" len="med"/>
-                    </a:lnT>
-                    <a:lnB w="6350" cap="flat" cmpd="sng" algn="ctr">
-                      <a:solidFill>
-                        <a:srgbClr val="DDE3F0"/>
-                      </a:solidFill>
-                      <a:prstDash val="solid"/>
-                      <a:round/>
-                      <a:headEnd type="none" w="med" len="med"/>
-                      <a:tailEnd type="none" w="med" len="med"/>
-                    </a:lnB>
-                  </a:tcPr>
-                </a:tc>
-                <a:tc>
-                  <a:txBody>
-                    <a:bodyPr/>
-                    <a:lstStyle/>
-                    <a:p>
-                      <a:pPr marL="0" indent="0" algn="l">
-                        <a:buNone/>
-                      </a:pPr>
-                      <a:r>
-                        <a:rPr lang="en-US" sz="1250" dirty="0">
-                          <a:solidFill>
-                            <a:srgbClr val="000000"/>
-                          </a:solidFill>
-                        </a:rPr>
-                        <a:t>base_url 끝에 /v1 포함 확인</a:t>
-                      </a:r>
-                      <a:endParaRPr lang="en-US" sz="1250" dirty="0"/>
-                    </a:p>
-                  </a:txBody>
-                  <a:tcPr>
-                    <a:lnL w="6350" cap="flat" cmpd="sng" algn="ctr">
-                      <a:solidFill>
-                        <a:srgbClr val="DDE3F0"/>
-                      </a:solidFill>
-                      <a:prstDash val="solid"/>
-                      <a:round/>
-                      <a:headEnd type="none" w="med" len="med"/>
-                      <a:tailEnd type="none" w="med" len="med"/>
-                    </a:lnL>
-                    <a:lnR w="6350" cap="flat" cmpd="sng" algn="ctr">
-                      <a:solidFill>
-                        <a:srgbClr val="DDE3F0"/>
-                      </a:solidFill>
-                      <a:prstDash val="solid"/>
-                      <a:round/>
-                      <a:headEnd type="none" w="med" len="med"/>
-                      <a:tailEnd type="none" w="med" len="med"/>
-                    </a:lnR>
-                    <a:lnT w="6350" cap="flat" cmpd="sng" algn="ctr">
-                      <a:solidFill>
-                        <a:srgbClr val="DDE3F0"/>
-                      </a:solidFill>
-                      <a:prstDash val="solid"/>
-                      <a:round/>
-                      <a:headEnd type="none" w="med" len="med"/>
-                      <a:tailEnd type="none" w="med" len="med"/>
-                    </a:lnT>
-                    <a:lnB w="6350" cap="flat" cmpd="sng" algn="ctr">
-                      <a:solidFill>
-                        <a:srgbClr val="DDE3F0"/>
-                      </a:solidFill>
-                      <a:prstDash val="solid"/>
-                      <a:round/>
-                      <a:headEnd type="none" w="med" len="med"/>
-                      <a:tailEnd type="none" w="med" len="med"/>
-                    </a:lnB>
-                  </a:tcPr>
-                </a:tc>
-                <a:extLst>
-                  <a:ext uri="{0D108BD9-81ED-4DB2-BD59-A6C34878D82A}">
-                    <a16:rowId xmlns:a16="http://schemas.microsoft.com/office/drawing/2014/main" val="10004"/>
-                  </a:ext>
-                </a:extLst>
-              </a:tr>
-              <a:tr h="548640">
-                <a:tc>
-                  <a:txBody>
-                    <a:bodyPr/>
-                    <a:lstStyle/>
-                    <a:p>
-                      <a:pPr marL="0" indent="0" algn="l">
-                        <a:buNone/>
-                      </a:pPr>
-                      <a:r>
-                        <a:rPr lang="en-US" sz="1250" dirty="0">
-                          <a:solidFill>
-                            <a:srgbClr val="000000"/>
-                          </a:solidFill>
-                        </a:rPr>
-                        <a:t>429 Too Many Requests</a:t>
-                      </a:r>
-                      <a:endParaRPr lang="en-US" sz="1250" dirty="0"/>
-                    </a:p>
-                  </a:txBody>
-                  <a:tcPr>
-                    <a:lnL w="6350" cap="flat" cmpd="sng" algn="ctr">
-                      <a:solidFill>
-                        <a:srgbClr val="DDE3F0"/>
-                      </a:solidFill>
-                      <a:prstDash val="solid"/>
-                      <a:round/>
-                      <a:headEnd type="none" w="med" len="med"/>
-                      <a:tailEnd type="none" w="med" len="med"/>
-                    </a:lnL>
-                    <a:lnR w="6350" cap="flat" cmpd="sng" algn="ctr">
-                      <a:solidFill>
-                        <a:srgbClr val="DDE3F0"/>
-                      </a:solidFill>
-                      <a:prstDash val="solid"/>
-                      <a:round/>
-                      <a:headEnd type="none" w="med" len="med"/>
-                      <a:tailEnd type="none" w="med" len="med"/>
-                    </a:lnR>
-                    <a:lnT w="6350" cap="flat" cmpd="sng" algn="ctr">
-                      <a:solidFill>
-                        <a:srgbClr val="DDE3F0"/>
-                      </a:solidFill>
-                      <a:prstDash val="solid"/>
-                      <a:round/>
-                      <a:headEnd type="none" w="med" len="med"/>
-                      <a:tailEnd type="none" w="med" len="med"/>
-                    </a:lnT>
-                    <a:lnB w="6350" cap="flat" cmpd="sng" algn="ctr">
-                      <a:solidFill>
-                        <a:srgbClr val="DDE3F0"/>
-                      </a:solidFill>
-                      <a:prstDash val="solid"/>
-                      <a:round/>
-                      <a:headEnd type="none" w="med" len="med"/>
-                      <a:tailEnd type="none" w="med" len="med"/>
-                    </a:lnB>
-                  </a:tcPr>
-                </a:tc>
-                <a:tc>
-                  <a:txBody>
-                    <a:bodyPr/>
-                    <a:lstStyle/>
-                    <a:p>
-                      <a:pPr marL="0" indent="0" algn="l">
-                        <a:buNone/>
-                      </a:pPr>
-                      <a:r>
-                        <a:rPr lang="en-US" sz="1250" dirty="0">
-                          <a:solidFill>
-                            <a:srgbClr val="000000"/>
-                          </a:solidFill>
-                        </a:rPr>
-                        <a:t>Rate limit 초과 (Gemini 30 RPM 한도)</a:t>
-                      </a:r>
-                      <a:endParaRPr lang="en-US" sz="1250" dirty="0"/>
-                    </a:p>
-                  </a:txBody>
-                  <a:tcPr>
-                    <a:lnL w="6350" cap="flat" cmpd="sng" algn="ctr">
-                      <a:solidFill>
-                        <a:srgbClr val="DDE3F0"/>
-                      </a:solidFill>
-                      <a:prstDash val="solid"/>
-                      <a:round/>
-                      <a:headEnd type="none" w="med" len="med"/>
-                      <a:tailEnd type="none" w="med" len="med"/>
-                    </a:lnL>
-                    <a:lnR w="6350" cap="flat" cmpd="sng" algn="ctr">
-                      <a:solidFill>
-                        <a:srgbClr val="DDE3F0"/>
-                      </a:solidFill>
-                      <a:prstDash val="solid"/>
-                      <a:round/>
-                      <a:headEnd type="none" w="med" len="med"/>
-                      <a:tailEnd type="none" w="med" len="med"/>
-                    </a:lnR>
-                    <a:lnT w="6350" cap="flat" cmpd="sng" algn="ctr">
-                      <a:solidFill>
-                        <a:srgbClr val="DDE3F0"/>
-                      </a:solidFill>
-                      <a:prstDash val="solid"/>
-                      <a:round/>
-                      <a:headEnd type="none" w="med" len="med"/>
-                      <a:tailEnd type="none" w="med" len="med"/>
-                    </a:lnT>
-                    <a:lnB w="6350" cap="flat" cmpd="sng" algn="ctr">
-                      <a:solidFill>
-                        <a:srgbClr val="DDE3F0"/>
-                      </a:solidFill>
-                      <a:prstDash val="solid"/>
-                      <a:round/>
-                      <a:headEnd type="none" w="med" len="med"/>
-                      <a:tailEnd type="none" w="med" len="med"/>
-                    </a:lnB>
-                  </a:tcPr>
-                </a:tc>
-                <a:tc>
-                  <a:txBody>
-                    <a:bodyPr/>
-                    <a:lstStyle/>
-                    <a:p>
-                      <a:pPr marL="0" indent="0" algn="l">
-                        <a:buNone/>
-                      </a:pPr>
-                      <a:r>
-                        <a:rPr lang="en-US" sz="1250" dirty="0">
-                          <a:solidFill>
-                            <a:srgbClr val="000000"/>
-                          </a:solidFill>
-                        </a:rPr>
-                        <a:t>잠시 기다린 후 재시도</a:t>
-                      </a:r>
-                      <a:endParaRPr lang="en-US" sz="1250" dirty="0"/>
-                    </a:p>
-                  </a:txBody>
-                  <a:tcPr>
-                    <a:lnL w="6350" cap="flat" cmpd="sng" algn="ctr">
-                      <a:solidFill>
-                        <a:srgbClr val="DDE3F0"/>
-                      </a:solidFill>
-                      <a:prstDash val="solid"/>
-                      <a:round/>
-                      <a:headEnd type="none" w="med" len="med"/>
-                      <a:tailEnd type="none" w="med" len="med"/>
-                    </a:lnL>
-                    <a:lnR w="6350" cap="flat" cmpd="sng" algn="ctr">
-                      <a:solidFill>
-                        <a:srgbClr val="DDE3F0"/>
-                      </a:solidFill>
-                      <a:prstDash val="solid"/>
-                      <a:round/>
-                      <a:headEnd type="none" w="med" len="med"/>
-                      <a:tailEnd type="none" w="med" len="med"/>
-                    </a:lnR>
-                    <a:lnT w="6350" cap="flat" cmpd="sng" algn="ctr">
-                      <a:solidFill>
-                        <a:srgbClr val="DDE3F0"/>
-                      </a:solidFill>
-                      <a:prstDash val="solid"/>
-                      <a:round/>
-                      <a:headEnd type="none" w="med" len="med"/>
-                      <a:tailEnd type="none" w="med" len="med"/>
-                    </a:lnT>
-                    <a:lnB w="6350" cap="flat" cmpd="sng" algn="ctr">
-                      <a:solidFill>
-                        <a:srgbClr val="DDE3F0"/>
-                      </a:solidFill>
-                      <a:prstDash val="solid"/>
-                      <a:round/>
-                      <a:headEnd type="none" w="med" len="med"/>
-                      <a:tailEnd type="none" w="med" len="med"/>
-                    </a:lnB>
-                  </a:tcPr>
-                </a:tc>
-                <a:extLst>
-                  <a:ext uri="{0D108BD9-81ED-4DB2-BD59-A6C34878D82A}">
-                    <a16:rowId xmlns:a16="http://schemas.microsoft.com/office/drawing/2014/main" val="10005"/>
-                  </a:ext>
-                </a:extLst>
-              </a:tr>
-              <a:tr h="548640">
-                <a:tc>
-                  <a:txBody>
-                    <a:bodyPr/>
-                    <a:lstStyle/>
-                    <a:p>
-                      <a:pPr marL="0" indent="0" algn="l">
-                        <a:buNone/>
-                      </a:pPr>
-                      <a:r>
-                        <a:rPr lang="en-US" sz="1250" dirty="0">
-                          <a:solidFill>
-                            <a:srgbClr val="000000"/>
-                          </a:solidFill>
-                        </a:rPr>
-                        <a:t>model not found</a:t>
-                      </a:r>
-                      <a:endParaRPr lang="en-US" sz="1250" dirty="0"/>
-                    </a:p>
-                  </a:txBody>
-                  <a:tcPr>
-                    <a:lnL w="6350" cap="flat" cmpd="sng" algn="ctr">
-                      <a:solidFill>
-                        <a:srgbClr val="DDE3F0"/>
-                      </a:solidFill>
-                      <a:prstDash val="solid"/>
-                      <a:round/>
-                      <a:headEnd type="none" w="med" len="med"/>
-                      <a:tailEnd type="none" w="med" len="med"/>
-                    </a:lnL>
-                    <a:lnR w="6350" cap="flat" cmpd="sng" algn="ctr">
-                      <a:solidFill>
-                        <a:srgbClr val="DDE3F0"/>
-                      </a:solidFill>
-                      <a:prstDash val="solid"/>
-                      <a:round/>
-                      <a:headEnd type="none" w="med" len="med"/>
-                      <a:tailEnd type="none" w="med" len="med"/>
-                    </a:lnR>
-                    <a:lnT w="6350" cap="flat" cmpd="sng" algn="ctr">
-                      <a:solidFill>
-                        <a:srgbClr val="DDE3F0"/>
-                      </a:solidFill>
-                      <a:prstDash val="solid"/>
-                      <a:round/>
-                      <a:headEnd type="none" w="med" len="med"/>
-                      <a:tailEnd type="none" w="med" len="med"/>
-                    </a:lnT>
-                    <a:lnB w="6350" cap="flat" cmpd="sng" algn="ctr">
-                      <a:solidFill>
-                        <a:srgbClr val="DDE3F0"/>
-                      </a:solidFill>
-                      <a:prstDash val="solid"/>
-                      <a:round/>
-                      <a:headEnd type="none" w="med" len="med"/>
-                      <a:tailEnd type="none" w="med" len="med"/>
-                    </a:lnB>
-                  </a:tcPr>
-                </a:tc>
-                <a:tc>
-                  <a:txBody>
-                    <a:bodyPr/>
-                    <a:lstStyle/>
-                    <a:p>
-                      <a:pPr marL="0" indent="0" algn="l">
-                        <a:buNone/>
-                      </a:pPr>
-                      <a:r>
-                        <a:rPr lang="en-US" sz="1250" dirty="0">
-                          <a:solidFill>
-                            <a:srgbClr val="000000"/>
-                          </a:solidFill>
-                        </a:rPr>
-                        <a:t>모델명 오류</a:t>
-                      </a:r>
-                      <a:endParaRPr lang="en-US" sz="1250" dirty="0"/>
-                    </a:p>
-                  </a:txBody>
-                  <a:tcPr>
-                    <a:lnL w="6350" cap="flat" cmpd="sng" algn="ctr">
-                      <a:solidFill>
-                        <a:srgbClr val="DDE3F0"/>
-                      </a:solidFill>
-                      <a:prstDash val="solid"/>
-                      <a:round/>
-                      <a:headEnd type="none" w="med" len="med"/>
-                      <a:tailEnd type="none" w="med" len="med"/>
-                    </a:lnL>
-                    <a:lnR w="6350" cap="flat" cmpd="sng" algn="ctr">
-                      <a:solidFill>
-                        <a:srgbClr val="DDE3F0"/>
-                      </a:solidFill>
-                      <a:prstDash val="solid"/>
-                      <a:round/>
-                      <a:headEnd type="none" w="med" len="med"/>
-                      <a:tailEnd type="none" w="med" len="med"/>
-                    </a:lnR>
-                    <a:lnT w="6350" cap="flat" cmpd="sng" algn="ctr">
-                      <a:solidFill>
-                        <a:srgbClr val="DDE3F0"/>
-                      </a:solidFill>
-                      <a:prstDash val="solid"/>
-                      <a:round/>
-                      <a:headEnd type="none" w="med" len="med"/>
-                      <a:tailEnd type="none" w="med" len="med"/>
-                    </a:lnT>
-                    <a:lnB w="6350" cap="flat" cmpd="sng" algn="ctr">
-                      <a:solidFill>
-                        <a:srgbClr val="DDE3F0"/>
-                      </a:solidFill>
-                      <a:prstDash val="solid"/>
-                      <a:round/>
-                      <a:headEnd type="none" w="med" len="med"/>
-                      <a:tailEnd type="none" w="med" len="med"/>
-                    </a:lnB>
-                  </a:tcPr>
-                </a:tc>
-                <a:tc>
-                  <a:txBody>
-                    <a:bodyPr/>
-                    <a:lstStyle/>
-                    <a:p>
-                      <a:pPr marL="0" indent="0" algn="l">
-                        <a:buNone/>
-                      </a:pPr>
-                      <a:r>
-                        <a:rPr lang="en-US" sz="1250" dirty="0">
-                          <a:solidFill>
-                            <a:srgbClr val="000000"/>
-                          </a:solidFill>
-                        </a:rPr>
-                        <a:t>"gemini-2.5-flash-lite" 확인</a:t>
-                      </a:r>
-                      <a:endParaRPr lang="en-US" sz="1250" dirty="0"/>
-                    </a:p>
-                  </a:txBody>
-                  <a:tcPr>
-                    <a:lnL w="6350" cap="flat" cmpd="sng" algn="ctr">
-                      <a:solidFill>
-                        <a:srgbClr val="DDE3F0"/>
-                      </a:solidFill>
-                      <a:prstDash val="solid"/>
-                      <a:round/>
-                      <a:headEnd type="none" w="med" len="med"/>
-                      <a:tailEnd type="none" w="med" len="med"/>
-                    </a:lnL>
-                    <a:lnR w="6350" cap="flat" cmpd="sng" algn="ctr">
-                      <a:solidFill>
-                        <a:srgbClr val="DDE3F0"/>
-                      </a:solidFill>
-                      <a:prstDash val="solid"/>
-                      <a:round/>
-                      <a:headEnd type="none" w="med" len="med"/>
-                      <a:tailEnd type="none" w="med" len="med"/>
-                    </a:lnR>
-                    <a:lnT w="6350" cap="flat" cmpd="sng" algn="ctr">
-                      <a:solidFill>
-                        <a:srgbClr val="DDE3F0"/>
-                      </a:solidFill>
-                      <a:prstDash val="solid"/>
-                      <a:round/>
-                      <a:headEnd type="none" w="med" len="med"/>
-                      <a:tailEnd type="none" w="med" len="med"/>
-                    </a:lnT>
-                    <a:lnB w="6350" cap="flat" cmpd="sng" algn="ctr">
-                      <a:solidFill>
-                        <a:srgbClr val="DDE3F0"/>
-                      </a:solidFill>
-                      <a:prstDash val="solid"/>
-                      <a:round/>
-                      <a:headEnd type="none" w="med" len="med"/>
-                      <a:tailEnd type="none" w="med" len="med"/>
-                    </a:lnB>
-                  </a:tcPr>
-                </a:tc>
-                <a:extLst>
-                  <a:ext uri="{0D108BD9-81ED-4DB2-BD59-A6C34878D82A}">
-                    <a16:rowId xmlns:a16="http://schemas.microsoft.com/office/drawing/2014/main" val="10006"/>
-                  </a:ext>
-                </a:extLst>
-              </a:tr>
-            </a:tbl>
-          </a:graphicData>
-        </a:graphic>
-      </p:graphicFrame>
-    </p:spTree>
-  </p:cSld>
-  <p:clrMapOvr>
-    <a:masterClrMapping/>
-  </p:clrMapOvr>
-</p:sld>
-</file>
-
 <file path=ppt/slides/slide2.xml><?xml version="1.0" encoding="utf-8"?>
 <p:sld xmlns:a="http://schemas.openxmlformats.org/drawingml/2006/main" xmlns:r="http://schemas.openxmlformats.org/officeDocument/2006/relationships" xmlns:p="http://schemas.openxmlformats.org/presentationml/2006/main">
   <p:cSld name="Slide 2">
@@ -12791,7 +9971,7 @@
                   <a:srgbClr val="1A2035"/>
                 </a:solidFill>
               </a:rPr>
-              <a:t>nb01 LiteLLM proxy 연결 확인</a:t>
+              <a:t>nb01  RAG · VectorDB 실습</a:t>
             </a:r>
             <a:endParaRPr lang="en-US" sz="1200" dirty="0"/>
           </a:p>
@@ -13289,7 +10469,7 @@
                   <a:srgbClr val="E8A825"/>
                 </a:solidFill>
               </a:rPr>
-              <a:t>실습으로 이어집니다 →  nb01 / nb02 / nb03</a:t>
+              <a:t>실습으로 이어집니다 →  nb01 / nb02</a:t>
             </a:r>
             <a:endParaRPr lang="en-US" sz="1500" dirty="0"/>
           </a:p>

</xml_diff>